<commit_message>
Primary version of presentation slide is complete
</commit_message>
<xml_diff>
--- a/Presentation/Presentation_Slide.pptx
+++ b/Presentation/Presentation_Slide.pptx
@@ -5,7 +5,7 @@
     <p:sldMasterId id="2147483648" r:id="rId1"/>
   </p:sldMasterIdLst>
   <p:notesMasterIdLst>
-    <p:notesMasterId r:id="rId25"/>
+    <p:notesMasterId r:id="rId19"/>
   </p:notesMasterIdLst>
   <p:sldIdLst>
     <p:sldId id="256" r:id="rId2"/>
@@ -13,24 +13,18 @@
     <p:sldId id="279" r:id="rId4"/>
     <p:sldId id="277" r:id="rId5"/>
     <p:sldId id="259" r:id="rId6"/>
-    <p:sldId id="280" r:id="rId7"/>
-    <p:sldId id="260" r:id="rId8"/>
-    <p:sldId id="261" r:id="rId9"/>
-    <p:sldId id="262" r:id="rId10"/>
-    <p:sldId id="282" r:id="rId11"/>
-    <p:sldId id="263" r:id="rId12"/>
-    <p:sldId id="264" r:id="rId13"/>
-    <p:sldId id="265" r:id="rId14"/>
+    <p:sldId id="285" r:id="rId7"/>
+    <p:sldId id="280" r:id="rId8"/>
+    <p:sldId id="260" r:id="rId9"/>
+    <p:sldId id="261" r:id="rId10"/>
+    <p:sldId id="262" r:id="rId11"/>
+    <p:sldId id="282" r:id="rId12"/>
+    <p:sldId id="263" r:id="rId13"/>
+    <p:sldId id="264" r:id="rId14"/>
     <p:sldId id="266" r:id="rId15"/>
     <p:sldId id="267" r:id="rId16"/>
     <p:sldId id="268" r:id="rId17"/>
-    <p:sldId id="269" r:id="rId18"/>
-    <p:sldId id="270" r:id="rId19"/>
-    <p:sldId id="271" r:id="rId20"/>
-    <p:sldId id="272" r:id="rId21"/>
-    <p:sldId id="273" r:id="rId22"/>
-    <p:sldId id="274" r:id="rId23"/>
-    <p:sldId id="275" r:id="rId24"/>
+    <p:sldId id="283" r:id="rId18"/>
   </p:sldIdLst>
   <p:sldSz cx="9144000" cy="6858000" type="screen4x3"/>
   <p:notesSz cx="6858000" cy="9144000"/>
@@ -631,7 +625,7 @@
             <a:fld id="{1FA01549-A684-4EF8-B375-4FA6F97410B2}" type="slidenum">
               <a:rPr lang="en-US" smtClean="0"/>
               <a:pPr/>
-              <a:t>7</a:t>
+              <a:t>8</a:t>
             </a:fld>
             <a:endParaRPr lang="en-US"/>
           </a:p>
@@ -826,6 +820,7 @@
           <a:p>
             <a:fld id="{E5011768-7637-4D51-85C0-F985CC0D3053}" type="datetime1">
               <a:rPr lang="en-US" smtClean="0"/>
+              <a:pPr/>
               <a:t>28/09/2013</a:t>
             </a:fld>
             <a:endParaRPr lang="en-US"/>
@@ -992,6 +987,7 @@
           <a:p>
             <a:fld id="{A6695160-AD22-4B29-B338-A2FA883490CB}" type="datetime1">
               <a:rPr lang="en-US" smtClean="0"/>
+              <a:pPr/>
               <a:t>28/09/2013</a:t>
             </a:fld>
             <a:endParaRPr lang="en-US"/>
@@ -1168,6 +1164,7 @@
           <a:p>
             <a:fld id="{5FD137B7-8E35-4086-B14F-D22793E929BA}" type="datetime1">
               <a:rPr lang="en-US" smtClean="0"/>
+              <a:pPr/>
               <a:t>28/09/2013</a:t>
             </a:fld>
             <a:endParaRPr lang="en-US"/>
@@ -1334,6 +1331,7 @@
           <a:p>
             <a:fld id="{03DACB65-7EC6-4BB4-A341-FB78540C5188}" type="datetime1">
               <a:rPr lang="en-US" smtClean="0"/>
+              <a:pPr/>
               <a:t>28/09/2013</a:t>
             </a:fld>
             <a:endParaRPr lang="en-US"/>
@@ -1576,6 +1574,7 @@
           <a:p>
             <a:fld id="{E8D044E0-1753-44D3-AF1F-E461CA2580F0}" type="datetime1">
               <a:rPr lang="en-US" smtClean="0"/>
+              <a:pPr/>
               <a:t>28/09/2013</a:t>
             </a:fld>
             <a:endParaRPr lang="en-US"/>
@@ -1860,6 +1859,7 @@
           <a:p>
             <a:fld id="{01A60C08-4C1E-4A5E-8023-A5E0FC3C95BF}" type="datetime1">
               <a:rPr lang="en-US" smtClean="0"/>
+              <a:pPr/>
               <a:t>28/09/2013</a:t>
             </a:fld>
             <a:endParaRPr lang="en-US"/>
@@ -2278,6 +2278,7 @@
           <a:p>
             <a:fld id="{09D47052-F110-4E3C-AECC-18C80C202A55}" type="datetime1">
               <a:rPr lang="en-US" smtClean="0"/>
+              <a:pPr/>
               <a:t>28/09/2013</a:t>
             </a:fld>
             <a:endParaRPr lang="en-US"/>
@@ -2392,6 +2393,7 @@
           <a:p>
             <a:fld id="{99128FCB-849C-48BB-9937-B98B744F5566}" type="datetime1">
               <a:rPr lang="en-US" smtClean="0"/>
+              <a:pPr/>
               <a:t>28/09/2013</a:t>
             </a:fld>
             <a:endParaRPr lang="en-US"/>
@@ -2483,6 +2485,7 @@
           <a:p>
             <a:fld id="{6F9C919F-19E4-4AE1-9EDB-563194514575}" type="datetime1">
               <a:rPr lang="en-US" smtClean="0"/>
+              <a:pPr/>
               <a:t>28/09/2013</a:t>
             </a:fld>
             <a:endParaRPr lang="en-US"/>
@@ -2756,6 +2759,7 @@
           <a:p>
             <a:fld id="{2785452C-574A-463A-8C57-608FFEEC5D39}" type="datetime1">
               <a:rPr lang="en-US" smtClean="0"/>
+              <a:pPr/>
               <a:t>28/09/2013</a:t>
             </a:fld>
             <a:endParaRPr lang="en-US"/>
@@ -3005,6 +3009,7 @@
           <a:p>
             <a:fld id="{52B408A9-E92F-41C6-B584-B3E4F022331D}" type="datetime1">
               <a:rPr lang="en-US" smtClean="0"/>
+              <a:pPr/>
               <a:t>28/09/2013</a:t>
             </a:fld>
             <a:endParaRPr lang="en-US"/>
@@ -3214,6 +3219,7 @@
           <a:p>
             <a:fld id="{2E53E5DE-F854-4244-8E83-4E7481A6E9A6}" type="datetime1">
               <a:rPr lang="en-US" smtClean="0"/>
+              <a:pPr/>
               <a:t>28/09/2013</a:t>
             </a:fld>
             <a:endParaRPr lang="en-US"/>
@@ -3714,6 +3720,132 @@
         </p:nvSpPr>
         <p:spPr/>
         <p:txBody>
+          <a:bodyPr/>
+          <a:lstStyle/>
+          <a:p>
+            <a:r>
+              <a:rPr lang="en-US" dirty="0" smtClean="0"/>
+              <a:t>Analyze Floor Plan</a:t>
+            </a:r>
+            <a:endParaRPr lang="en-US" dirty="0"/>
+          </a:p>
+        </p:txBody>
+      </p:sp>
+      <p:pic>
+        <p:nvPicPr>
+          <p:cNvPr id="6" name="Content Placeholder 5" descr="segmented_map_of_IPA.png"/>
+          <p:cNvPicPr>
+            <a:picLocks noGrp="1" noChangeAspect="1"/>
+          </p:cNvPicPr>
+          <p:nvPr>
+            <p:ph idx="1"/>
+          </p:nvPr>
+        </p:nvPicPr>
+        <p:blipFill>
+          <a:blip r:embed="rId2"/>
+          <a:stretch>
+            <a:fillRect/>
+          </a:stretch>
+        </p:blipFill>
+        <p:spPr>
+          <a:xfrm>
+            <a:off x="1981200" y="1447800"/>
+            <a:ext cx="5346215" cy="5029200"/>
+          </a:xfrm>
+        </p:spPr>
+      </p:pic>
+      <p:pic>
+        <p:nvPicPr>
+          <p:cNvPr id="4" name="Picture 3" descr="ipa_logo_high_quality_modified.png"/>
+          <p:cNvPicPr>
+            <a:picLocks noChangeAspect="1"/>
+          </p:cNvPicPr>
+          <p:nvPr/>
+        </p:nvPicPr>
+        <p:blipFill>
+          <a:blip r:embed="rId3" cstate="print"/>
+          <a:stretch>
+            <a:fillRect/>
+          </a:stretch>
+        </p:blipFill>
+        <p:spPr>
+          <a:xfrm>
+            <a:off x="7239000" y="76200"/>
+            <a:ext cx="1828800" cy="514567"/>
+          </a:xfrm>
+          <a:prstGeom prst="rect">
+            <a:avLst/>
+          </a:prstGeom>
+        </p:spPr>
+      </p:pic>
+      <p:sp>
+        <p:nvSpPr>
+          <p:cNvPr id="5" name="Slide Number Placeholder 4"/>
+          <p:cNvSpPr>
+            <a:spLocks noGrp="1"/>
+          </p:cNvSpPr>
+          <p:nvPr>
+            <p:ph type="sldNum" sz="quarter" idx="12"/>
+          </p:nvPr>
+        </p:nvSpPr>
+        <p:spPr/>
+        <p:txBody>
+          <a:bodyPr/>
+          <a:lstStyle/>
+          <a:p>
+            <a:fld id="{41F30F6B-FB39-4EE3-BB70-00F6893EC94F}" type="slidenum">
+              <a:rPr lang="en-US" smtClean="0"/>
+              <a:pPr/>
+              <a:t>10</a:t>
+            </a:fld>
+            <a:endParaRPr lang="en-US"/>
+          </a:p>
+        </p:txBody>
+      </p:sp>
+    </p:spTree>
+  </p:cSld>
+  <p:clrMapOvr>
+    <a:masterClrMapping/>
+  </p:clrMapOvr>
+  <p:timing>
+    <p:tnLst>
+      <p:par>
+        <p:cTn id="1" dur="indefinite" restart="never" nodeType="tmRoot"/>
+      </p:par>
+    </p:tnLst>
+  </p:timing>
+</p:sld>
+</file>
+
+<file path=ppt/slides/slide11.xml><?xml version="1.0" encoding="utf-8"?>
+<p:sld xmlns:a="http://schemas.openxmlformats.org/drawingml/2006/main" xmlns:r="http://schemas.openxmlformats.org/officeDocument/2006/relationships" xmlns:p="http://schemas.openxmlformats.org/presentationml/2006/main">
+  <p:cSld>
+    <p:spTree>
+      <p:nvGrpSpPr>
+        <p:cNvPr id="1" name=""/>
+        <p:cNvGrpSpPr/>
+        <p:nvPr/>
+      </p:nvGrpSpPr>
+      <p:grpSpPr>
+        <a:xfrm>
+          <a:off x="0" y="0"/>
+          <a:ext cx="0" cy="0"/>
+          <a:chOff x="0" y="0"/>
+          <a:chExt cx="0" cy="0"/>
+        </a:xfrm>
+      </p:grpSpPr>
+      <p:sp>
+        <p:nvSpPr>
+          <p:cNvPr id="2" name="Title 1"/>
+          <p:cNvSpPr>
+            <a:spLocks noGrp="1"/>
+          </p:cNvSpPr>
+          <p:nvPr>
+            <p:ph type="title"/>
+          </p:nvPr>
+        </p:nvSpPr>
+        <p:spPr/>
+        <p:txBody>
           <a:bodyPr>
             <a:normAutofit fontScale="90000"/>
           </a:bodyPr>
@@ -3799,7 +3931,7 @@
             <a:fld id="{41F30F6B-FB39-4EE3-BB70-00F6893EC94F}" type="slidenum">
               <a:rPr lang="en-US" smtClean="0"/>
               <a:pPr/>
-              <a:t>10</a:t>
+              <a:t>11</a:t>
             </a:fld>
             <a:endParaRPr lang="en-US"/>
           </a:p>
@@ -3820,7 +3952,7 @@
 </p:sld>
 </file>
 
-<file path=ppt/slides/slide11.xml><?xml version="1.0" encoding="utf-8"?>
+<file path=ppt/slides/slide12.xml><?xml version="1.0" encoding="utf-8"?>
 <p:sld xmlns:a="http://schemas.openxmlformats.org/drawingml/2006/main" xmlns:r="http://schemas.openxmlformats.org/officeDocument/2006/relationships" xmlns:p="http://schemas.openxmlformats.org/presentationml/2006/main">
   <p:cSld>
     <p:spTree>
@@ -3868,15 +4000,7 @@
             </a:br>
             <a:r>
               <a:rPr lang="en-US" dirty="0" smtClean="0"/>
-              <a:t> And Go To </a:t>
-            </a:r>
-            <a:r>
-              <a:rPr lang="en-US" dirty="0" smtClean="0"/>
-              <a:t>T</a:t>
-            </a:r>
-            <a:r>
-              <a:rPr lang="en-US" dirty="0" smtClean="0"/>
-              <a:t>he Room Location</a:t>
+              <a:t> And Go To The Room Location</a:t>
             </a:r>
             <a:endParaRPr lang="en-US" dirty="0"/>
           </a:p>
@@ -3947,7 +4071,7 @@
             <a:fld id="{41F30F6B-FB39-4EE3-BB70-00F6893EC94F}" type="slidenum">
               <a:rPr lang="en-US" smtClean="0"/>
               <a:pPr/>
-              <a:t>11</a:t>
+              <a:t>12</a:t>
             </a:fld>
             <a:endParaRPr lang="en-US"/>
           </a:p>
@@ -3968,7 +4092,7 @@
 </p:sld>
 </file>
 
-<file path=ppt/slides/slide12.xml><?xml version="1.0" encoding="utf-8"?>
+<file path=ppt/slides/slide13.xml><?xml version="1.0" encoding="utf-8"?>
 <p:sld xmlns:a="http://schemas.openxmlformats.org/drawingml/2006/main" xmlns:r="http://schemas.openxmlformats.org/officeDocument/2006/relationships" xmlns:p="http://schemas.openxmlformats.org/presentationml/2006/main">
   <p:cSld>
     <p:spTree>
@@ -4073,7 +4197,7 @@
             <a:fld id="{41F30F6B-FB39-4EE3-BB70-00F6893EC94F}" type="slidenum">
               <a:rPr lang="en-US" smtClean="0"/>
               <a:pPr/>
-              <a:t>12</a:t>
+              <a:t>13</a:t>
             </a:fld>
             <a:endParaRPr lang="en-US"/>
           </a:p>
@@ -4094,7 +4218,1275 @@
 </p:sld>
 </file>
 
-<file path=ppt/slides/slide13.xml><?xml version="1.0" encoding="utf-8"?>
+<file path=ppt/slides/slide14.xml><?xml version="1.0" encoding="utf-8"?>
+<p:sld xmlns:a="http://schemas.openxmlformats.org/drawingml/2006/main" xmlns:r="http://schemas.openxmlformats.org/officeDocument/2006/relationships" xmlns:p="http://schemas.openxmlformats.org/presentationml/2006/main">
+  <p:cSld>
+    <p:spTree>
+      <p:nvGrpSpPr>
+        <p:cNvPr id="1" name=""/>
+        <p:cNvGrpSpPr/>
+        <p:nvPr/>
+      </p:nvGrpSpPr>
+      <p:grpSpPr>
+        <a:xfrm>
+          <a:off x="0" y="0"/>
+          <a:ext cx="0" cy="0"/>
+          <a:chOff x="0" y="0"/>
+          <a:chExt cx="0" cy="0"/>
+        </a:xfrm>
+      </p:grpSpPr>
+      <p:sp>
+        <p:nvSpPr>
+          <p:cNvPr id="2" name="Title 1"/>
+          <p:cNvSpPr>
+            <a:spLocks noGrp="1"/>
+          </p:cNvSpPr>
+          <p:nvPr>
+            <p:ph type="title"/>
+          </p:nvPr>
+        </p:nvSpPr>
+        <p:spPr/>
+        <p:txBody>
+          <a:bodyPr>
+            <a:normAutofit/>
+          </a:bodyPr>
+          <a:lstStyle/>
+          <a:p>
+            <a:r>
+              <a:rPr lang="en-US" dirty="0" smtClean="0"/>
+              <a:t>Tasks of Mobile Cleaning Robot:</a:t>
+            </a:r>
+            <a:endParaRPr lang="en-US" dirty="0"/>
+          </a:p>
+        </p:txBody>
+      </p:sp>
+      <p:pic>
+        <p:nvPicPr>
+          <p:cNvPr id="6" name="Content Placeholder 5" descr="Exploration_Detection_Cleaning.png"/>
+          <p:cNvPicPr>
+            <a:picLocks noGrp="1" noChangeAspect="1"/>
+          </p:cNvPicPr>
+          <p:nvPr>
+            <p:ph idx="1"/>
+          </p:nvPr>
+        </p:nvPicPr>
+        <p:blipFill>
+          <a:blip r:embed="rId2"/>
+          <a:stretch>
+            <a:fillRect/>
+          </a:stretch>
+        </p:blipFill>
+        <p:spPr>
+          <a:xfrm>
+            <a:off x="1066800" y="1371600"/>
+            <a:ext cx="6629400" cy="5334000"/>
+          </a:xfrm>
+        </p:spPr>
+      </p:pic>
+      <p:pic>
+        <p:nvPicPr>
+          <p:cNvPr id="4" name="Picture 3" descr="ipa_logo_high_quality_modified.png"/>
+          <p:cNvPicPr>
+            <a:picLocks noChangeAspect="1"/>
+          </p:cNvPicPr>
+          <p:nvPr/>
+        </p:nvPicPr>
+        <p:blipFill>
+          <a:blip r:embed="rId3" cstate="print"/>
+          <a:stretch>
+            <a:fillRect/>
+          </a:stretch>
+        </p:blipFill>
+        <p:spPr>
+          <a:xfrm>
+            <a:off x="7239000" y="76200"/>
+            <a:ext cx="1828800" cy="514567"/>
+          </a:xfrm>
+          <a:prstGeom prst="rect">
+            <a:avLst/>
+          </a:prstGeom>
+        </p:spPr>
+      </p:pic>
+      <p:sp>
+        <p:nvSpPr>
+          <p:cNvPr id="5" name="Slide Number Placeholder 4"/>
+          <p:cNvSpPr>
+            <a:spLocks noGrp="1"/>
+          </p:cNvSpPr>
+          <p:nvPr>
+            <p:ph type="sldNum" sz="quarter" idx="12"/>
+          </p:nvPr>
+        </p:nvSpPr>
+        <p:spPr/>
+        <p:txBody>
+          <a:bodyPr/>
+          <a:lstStyle/>
+          <a:p>
+            <a:fld id="{41F30F6B-FB39-4EE3-BB70-00F6893EC94F}" type="slidenum">
+              <a:rPr lang="en-US" smtClean="0"/>
+              <a:pPr/>
+              <a:t>14</a:t>
+            </a:fld>
+            <a:endParaRPr lang="en-US"/>
+          </a:p>
+        </p:txBody>
+      </p:sp>
+    </p:spTree>
+  </p:cSld>
+  <p:clrMapOvr>
+    <a:masterClrMapping/>
+  </p:clrMapOvr>
+  <p:timing>
+    <p:tnLst>
+      <p:par>
+        <p:cTn id="1" dur="indefinite" restart="never" nodeType="tmRoot"/>
+      </p:par>
+    </p:tnLst>
+  </p:timing>
+</p:sld>
+</file>
+
+<file path=ppt/slides/slide15.xml><?xml version="1.0" encoding="utf-8"?>
+<p:sld xmlns:a="http://schemas.openxmlformats.org/drawingml/2006/main" xmlns:r="http://schemas.openxmlformats.org/officeDocument/2006/relationships" xmlns:p="http://schemas.openxmlformats.org/presentationml/2006/main">
+  <p:cSld>
+    <p:spTree>
+      <p:nvGrpSpPr>
+        <p:cNvPr id="1" name=""/>
+        <p:cNvGrpSpPr/>
+        <p:nvPr/>
+      </p:nvGrpSpPr>
+      <p:grpSpPr>
+        <a:xfrm>
+          <a:off x="0" y="0"/>
+          <a:ext cx="0" cy="0"/>
+          <a:chOff x="0" y="0"/>
+          <a:chExt cx="0" cy="0"/>
+        </a:xfrm>
+      </p:grpSpPr>
+      <p:sp>
+        <p:nvSpPr>
+          <p:cNvPr id="2" name="Title 1"/>
+          <p:cNvSpPr>
+            <a:spLocks noGrp="1"/>
+          </p:cNvSpPr>
+          <p:nvPr>
+            <p:ph type="title"/>
+          </p:nvPr>
+        </p:nvSpPr>
+        <p:spPr/>
+        <p:txBody>
+          <a:bodyPr/>
+          <a:lstStyle/>
+          <a:p>
+            <a:r>
+              <a:rPr lang="en-US" dirty="0" smtClean="0"/>
+              <a:t>Video of Exploration Algorithm</a:t>
+            </a:r>
+            <a:endParaRPr lang="en-US" dirty="0"/>
+          </a:p>
+        </p:txBody>
+      </p:sp>
+      <p:pic>
+        <p:nvPicPr>
+          <p:cNvPr id="4" name="Picture 3" descr="ipa_logo_high_quality_modified.png"/>
+          <p:cNvPicPr>
+            <a:picLocks noChangeAspect="1"/>
+          </p:cNvPicPr>
+          <p:nvPr/>
+        </p:nvPicPr>
+        <p:blipFill>
+          <a:blip r:embed="rId3" cstate="print"/>
+          <a:stretch>
+            <a:fillRect/>
+          </a:stretch>
+        </p:blipFill>
+        <p:spPr>
+          <a:xfrm>
+            <a:off x="7239000" y="76200"/>
+            <a:ext cx="1828800" cy="514567"/>
+          </a:xfrm>
+          <a:prstGeom prst="rect">
+            <a:avLst/>
+          </a:prstGeom>
+        </p:spPr>
+      </p:pic>
+      <p:sp>
+        <p:nvSpPr>
+          <p:cNvPr id="5" name="Slide Number Placeholder 4"/>
+          <p:cNvSpPr>
+            <a:spLocks noGrp="1"/>
+          </p:cNvSpPr>
+          <p:nvPr>
+            <p:ph type="sldNum" sz="quarter" idx="12"/>
+          </p:nvPr>
+        </p:nvSpPr>
+        <p:spPr/>
+        <p:txBody>
+          <a:bodyPr/>
+          <a:lstStyle/>
+          <a:p>
+            <a:fld id="{41F30F6B-FB39-4EE3-BB70-00F6893EC94F}" type="slidenum">
+              <a:rPr lang="en-US" smtClean="0"/>
+              <a:pPr/>
+              <a:t>15</a:t>
+            </a:fld>
+            <a:endParaRPr lang="en-US"/>
+          </a:p>
+        </p:txBody>
+      </p:sp>
+      <p:pic>
+        <p:nvPicPr>
+          <p:cNvPr id="6" name="smach_exploration_algorithm_simulation_video">
+            <a:hlinkClick r:id="" action="ppaction://media"/>
+          </p:cNvPr>
+          <p:cNvPicPr>
+            <a:picLocks noGrp="1" noRot="1" noChangeAspect="1"/>
+          </p:cNvPicPr>
+          <p:nvPr>
+            <p:ph idx="1"/>
+            <a:videoFile r:link="rId1"/>
+          </p:nvPr>
+        </p:nvPicPr>
+        <p:blipFill>
+          <a:blip r:embed="rId4"/>
+          <a:stretch>
+            <a:fillRect/>
+          </a:stretch>
+        </p:blipFill>
+        <p:spPr>
+          <a:xfrm>
+            <a:off x="914400" y="1447800"/>
+            <a:ext cx="7543800" cy="5029200"/>
+          </a:xfrm>
+          <a:prstGeom prst="rect">
+            <a:avLst/>
+          </a:prstGeom>
+        </p:spPr>
+      </p:pic>
+    </p:spTree>
+  </p:cSld>
+  <p:clrMapOvr>
+    <a:masterClrMapping/>
+  </p:clrMapOvr>
+  <p:timing>
+    <p:tnLst>
+      <p:par>
+        <p:cTn id="1" dur="indefinite" restart="never" nodeType="tmRoot">
+          <p:childTnLst>
+            <p:seq concurrent="1" nextAc="seek">
+              <p:cTn id="2" restart="whenNotActive" fill="hold" evtFilter="cancelBubble" nodeType="interactiveSeq">
+                <p:stCondLst>
+                  <p:cond evt="onClick" delay="0">
+                    <p:tgtEl>
+                      <p:spTgt spid="6"/>
+                    </p:tgtEl>
+                  </p:cond>
+                </p:stCondLst>
+                <p:endSync evt="end" delay="0">
+                  <p:rtn val="all"/>
+                </p:endSync>
+                <p:childTnLst>
+                  <p:par>
+                    <p:cTn id="3" fill="hold">
+                      <p:stCondLst>
+                        <p:cond delay="0"/>
+                      </p:stCondLst>
+                      <p:childTnLst>
+                        <p:par>
+                          <p:cTn id="4" fill="hold">
+                            <p:stCondLst>
+                              <p:cond delay="0"/>
+                            </p:stCondLst>
+                            <p:childTnLst>
+                              <p:par>
+                                <p:cTn id="5" presetID="2" presetClass="mediacall" presetSubtype="0" fill="hold" nodeType="clickEffect">
+                                  <p:stCondLst>
+                                    <p:cond delay="0"/>
+                                  </p:stCondLst>
+                                  <p:childTnLst>
+                                    <p:cmd type="call" cmd="togglePause">
+                                      <p:cBhvr>
+                                        <p:cTn id="6" dur="1" fill="hold"/>
+                                        <p:tgtEl>
+                                          <p:spTgt spid="6"/>
+                                        </p:tgtEl>
+                                      </p:cBhvr>
+                                    </p:cmd>
+                                  </p:childTnLst>
+                                </p:cTn>
+                              </p:par>
+                            </p:childTnLst>
+                          </p:cTn>
+                        </p:par>
+                      </p:childTnLst>
+                    </p:cTn>
+                  </p:par>
+                </p:childTnLst>
+              </p:cTn>
+              <p:nextCondLst>
+                <p:cond evt="onClick" delay="0">
+                  <p:tgtEl>
+                    <p:spTgt spid="6"/>
+                  </p:tgtEl>
+                </p:cond>
+              </p:nextCondLst>
+            </p:seq>
+            <p:video>
+              <p:cMediaNode>
+                <p:cTn id="7" fill="hold" display="0">
+                  <p:stCondLst>
+                    <p:cond delay="indefinite"/>
+                  </p:stCondLst>
+                  <p:endCondLst>
+                    <p:cond evt="onNext" delay="0">
+                      <p:tgtEl>
+                        <p:sldTgt/>
+                      </p:tgtEl>
+                    </p:cond>
+                    <p:cond evt="onPrev" delay="0">
+                      <p:tgtEl>
+                        <p:sldTgt/>
+                      </p:tgtEl>
+                    </p:cond>
+                  </p:endCondLst>
+                </p:cTn>
+                <p:tgtEl>
+                  <p:spTgt spid="6"/>
+                </p:tgtEl>
+              </p:cMediaNode>
+            </p:video>
+          </p:childTnLst>
+        </p:cTn>
+      </p:par>
+    </p:tnLst>
+  </p:timing>
+</p:sld>
+</file>
+
+<file path=ppt/slides/slide16.xml><?xml version="1.0" encoding="utf-8"?>
+<p:sld xmlns:a="http://schemas.openxmlformats.org/drawingml/2006/main" xmlns:r="http://schemas.openxmlformats.org/officeDocument/2006/relationships" xmlns:p="http://schemas.openxmlformats.org/presentationml/2006/main">
+  <p:cSld>
+    <p:spTree>
+      <p:nvGrpSpPr>
+        <p:cNvPr id="1" name=""/>
+        <p:cNvGrpSpPr/>
+        <p:nvPr/>
+      </p:nvGrpSpPr>
+      <p:grpSpPr>
+        <a:xfrm>
+          <a:off x="0" y="0"/>
+          <a:ext cx="0" cy="0"/>
+          <a:chOff x="0" y="0"/>
+          <a:chExt cx="0" cy="0"/>
+        </a:xfrm>
+      </p:grpSpPr>
+      <p:sp>
+        <p:nvSpPr>
+          <p:cNvPr id="2" name="Title 1"/>
+          <p:cNvSpPr>
+            <a:spLocks noGrp="1"/>
+          </p:cNvSpPr>
+          <p:nvPr>
+            <p:ph type="title"/>
+          </p:nvPr>
+        </p:nvSpPr>
+        <p:spPr/>
+        <p:txBody>
+          <a:bodyPr/>
+          <a:lstStyle/>
+          <a:p>
+            <a:r>
+              <a:rPr lang="en-US" dirty="0" smtClean="0"/>
+              <a:t>Conclusion</a:t>
+            </a:r>
+            <a:endParaRPr lang="en-US" dirty="0"/>
+          </a:p>
+        </p:txBody>
+      </p:sp>
+      <p:sp>
+        <p:nvSpPr>
+          <p:cNvPr id="3" name="Content Placeholder 2"/>
+          <p:cNvSpPr>
+            <a:spLocks noGrp="1"/>
+          </p:cNvSpPr>
+          <p:nvPr>
+            <p:ph idx="1"/>
+          </p:nvPr>
+        </p:nvSpPr>
+        <p:spPr/>
+        <p:txBody>
+          <a:bodyPr>
+            <a:normAutofit fontScale="92500"/>
+          </a:bodyPr>
+          <a:lstStyle/>
+          <a:p>
+            <a:pPr algn="just">
+              <a:buNone/>
+            </a:pPr>
+            <a:r>
+              <a:rPr lang="en-US" dirty="0" smtClean="0"/>
+              <a:t>Finally we can say, Exploration Algorithm is</a:t>
+            </a:r>
+          </a:p>
+          <a:p>
+            <a:pPr algn="just">
+              <a:buNone/>
+            </a:pPr>
+            <a:r>
+              <a:rPr lang="en-US" dirty="0" smtClean="0"/>
+              <a:t>essential for the autonomous cleaning job and is</a:t>
+            </a:r>
+          </a:p>
+          <a:p>
+            <a:pPr algn="just">
+              <a:buNone/>
+            </a:pPr>
+            <a:r>
+              <a:rPr lang="en-US" dirty="0" smtClean="0"/>
+              <a:t>independent of mobile platform and floor plan.</a:t>
+            </a:r>
+          </a:p>
+          <a:p>
+            <a:pPr algn="just">
+              <a:buNone/>
+            </a:pPr>
+            <a:r>
+              <a:rPr lang="en-US" dirty="0" smtClean="0"/>
+              <a:t>But this Exploration Algorithm we can use for</a:t>
+            </a:r>
+          </a:p>
+          <a:p>
+            <a:pPr algn="just">
+              <a:buNone/>
+            </a:pPr>
+            <a:r>
+              <a:rPr lang="en-US" dirty="0" smtClean="0"/>
+              <a:t>other purpose like switching-Off all the energy</a:t>
+            </a:r>
+          </a:p>
+          <a:p>
+            <a:pPr algn="just">
+              <a:buNone/>
+            </a:pPr>
+            <a:r>
+              <a:rPr lang="en-US" dirty="0" smtClean="0"/>
+              <a:t>device in a busy office at the end of a working day</a:t>
+            </a:r>
+          </a:p>
+          <a:p>
+            <a:pPr algn="just">
+              <a:buNone/>
+            </a:pPr>
+            <a:r>
+              <a:rPr lang="en-US" dirty="0" smtClean="0"/>
+              <a:t>o</a:t>
+            </a:r>
+            <a:r>
+              <a:rPr lang="en-US" dirty="0" smtClean="0"/>
+              <a:t>r during the weekend. We can also use this</a:t>
+            </a:r>
+          </a:p>
+          <a:p>
+            <a:pPr algn="just">
+              <a:buNone/>
+            </a:pPr>
+            <a:r>
+              <a:rPr lang="en-US" dirty="0" smtClean="0"/>
+              <a:t>algorithm </a:t>
+            </a:r>
+            <a:r>
+              <a:rPr lang="en-US" dirty="0" smtClean="0"/>
+              <a:t>in </a:t>
+            </a:r>
+            <a:r>
+              <a:rPr lang="en-US" dirty="0" smtClean="0"/>
+              <a:t>surveillance task and so on.</a:t>
+            </a:r>
+            <a:endParaRPr lang="en-US" dirty="0"/>
+          </a:p>
+        </p:txBody>
+      </p:sp>
+      <p:pic>
+        <p:nvPicPr>
+          <p:cNvPr id="4" name="Picture 3" descr="ipa_logo_high_quality_modified.png"/>
+          <p:cNvPicPr>
+            <a:picLocks noChangeAspect="1"/>
+          </p:cNvPicPr>
+          <p:nvPr/>
+        </p:nvPicPr>
+        <p:blipFill>
+          <a:blip r:embed="rId2" cstate="print"/>
+          <a:stretch>
+            <a:fillRect/>
+          </a:stretch>
+        </p:blipFill>
+        <p:spPr>
+          <a:xfrm>
+            <a:off x="7239000" y="76200"/>
+            <a:ext cx="1828800" cy="514567"/>
+          </a:xfrm>
+          <a:prstGeom prst="rect">
+            <a:avLst/>
+          </a:prstGeom>
+        </p:spPr>
+      </p:pic>
+      <p:sp>
+        <p:nvSpPr>
+          <p:cNvPr id="5" name="Slide Number Placeholder 4"/>
+          <p:cNvSpPr>
+            <a:spLocks noGrp="1"/>
+          </p:cNvSpPr>
+          <p:nvPr>
+            <p:ph type="sldNum" sz="quarter" idx="12"/>
+          </p:nvPr>
+        </p:nvSpPr>
+        <p:spPr/>
+        <p:txBody>
+          <a:bodyPr/>
+          <a:lstStyle/>
+          <a:p>
+            <a:fld id="{41F30F6B-FB39-4EE3-BB70-00F6893EC94F}" type="slidenum">
+              <a:rPr lang="en-US" smtClean="0"/>
+              <a:pPr/>
+              <a:t>16</a:t>
+            </a:fld>
+            <a:endParaRPr lang="en-US"/>
+          </a:p>
+        </p:txBody>
+      </p:sp>
+    </p:spTree>
+  </p:cSld>
+  <p:clrMapOvr>
+    <a:masterClrMapping/>
+  </p:clrMapOvr>
+  <p:timing>
+    <p:tnLst>
+      <p:par>
+        <p:cTn id="1" dur="indefinite" restart="never" nodeType="tmRoot"/>
+      </p:par>
+    </p:tnLst>
+  </p:timing>
+</p:sld>
+</file>
+
+<file path=ppt/slides/slide17.xml><?xml version="1.0" encoding="utf-8"?>
+<p:sld xmlns:a="http://schemas.openxmlformats.org/drawingml/2006/main" xmlns:r="http://schemas.openxmlformats.org/officeDocument/2006/relationships" xmlns:p="http://schemas.openxmlformats.org/presentationml/2006/main">
+  <p:cSld>
+    <p:spTree>
+      <p:nvGrpSpPr>
+        <p:cNvPr id="1" name=""/>
+        <p:cNvGrpSpPr/>
+        <p:nvPr/>
+      </p:nvGrpSpPr>
+      <p:grpSpPr>
+        <a:xfrm>
+          <a:off x="0" y="0"/>
+          <a:ext cx="0" cy="0"/>
+          <a:chOff x="0" y="0"/>
+          <a:chExt cx="0" cy="0"/>
+        </a:xfrm>
+      </p:grpSpPr>
+      <p:sp>
+        <p:nvSpPr>
+          <p:cNvPr id="2" name="Title 1"/>
+          <p:cNvSpPr>
+            <a:spLocks noGrp="1"/>
+          </p:cNvSpPr>
+          <p:nvPr>
+            <p:ph type="title"/>
+          </p:nvPr>
+        </p:nvSpPr>
+        <p:spPr/>
+        <p:txBody>
+          <a:bodyPr/>
+          <a:lstStyle/>
+          <a:p>
+            <a:endParaRPr lang="en-US"/>
+          </a:p>
+        </p:txBody>
+      </p:sp>
+      <p:sp>
+        <p:nvSpPr>
+          <p:cNvPr id="3" name="Content Placeholder 2"/>
+          <p:cNvSpPr>
+            <a:spLocks noGrp="1"/>
+          </p:cNvSpPr>
+          <p:nvPr>
+            <p:ph idx="1"/>
+          </p:nvPr>
+        </p:nvSpPr>
+        <p:spPr/>
+        <p:txBody>
+          <a:bodyPr/>
+          <a:lstStyle/>
+          <a:p>
+            <a:pPr>
+              <a:buNone/>
+            </a:pPr>
+            <a:endParaRPr lang="en-US" dirty="0" smtClean="0"/>
+          </a:p>
+          <a:p>
+            <a:pPr>
+              <a:buNone/>
+            </a:pPr>
+            <a:endParaRPr lang="en-US" dirty="0" smtClean="0"/>
+          </a:p>
+          <a:p>
+            <a:pPr algn="ctr">
+              <a:buNone/>
+            </a:pPr>
+            <a:r>
+              <a:rPr lang="en-US" dirty="0" smtClean="0"/>
+              <a:t>Thanks to all</a:t>
+            </a:r>
+            <a:endParaRPr lang="en-US" dirty="0"/>
+          </a:p>
+        </p:txBody>
+      </p:sp>
+      <p:sp>
+        <p:nvSpPr>
+          <p:cNvPr id="4" name="Slide Number Placeholder 3"/>
+          <p:cNvSpPr>
+            <a:spLocks noGrp="1"/>
+          </p:cNvSpPr>
+          <p:nvPr>
+            <p:ph type="sldNum" sz="quarter" idx="12"/>
+          </p:nvPr>
+        </p:nvSpPr>
+        <p:spPr/>
+        <p:txBody>
+          <a:bodyPr/>
+          <a:lstStyle/>
+          <a:p>
+            <a:fld id="{41F30F6B-FB39-4EE3-BB70-00F6893EC94F}" type="slidenum">
+              <a:rPr lang="en-US" smtClean="0"/>
+              <a:pPr/>
+              <a:t>17</a:t>
+            </a:fld>
+            <a:endParaRPr lang="en-US"/>
+          </a:p>
+        </p:txBody>
+      </p:sp>
+    </p:spTree>
+  </p:cSld>
+  <p:clrMapOvr>
+    <a:masterClrMapping/>
+  </p:clrMapOvr>
+  <p:timing>
+    <p:tnLst>
+      <p:par>
+        <p:cTn id="1" dur="indefinite" restart="never" nodeType="tmRoot"/>
+      </p:par>
+    </p:tnLst>
+  </p:timing>
+</p:sld>
+</file>
+
+<file path=ppt/slides/slide2.xml><?xml version="1.0" encoding="utf-8"?>
+<p:sld xmlns:a="http://schemas.openxmlformats.org/drawingml/2006/main" xmlns:r="http://schemas.openxmlformats.org/officeDocument/2006/relationships" xmlns:p="http://schemas.openxmlformats.org/presentationml/2006/main">
+  <p:cSld>
+    <p:spTree>
+      <p:nvGrpSpPr>
+        <p:cNvPr id="1" name=""/>
+        <p:cNvGrpSpPr/>
+        <p:nvPr/>
+      </p:nvGrpSpPr>
+      <p:grpSpPr>
+        <a:xfrm>
+          <a:off x="0" y="0"/>
+          <a:ext cx="0" cy="0"/>
+          <a:chOff x="0" y="0"/>
+          <a:chExt cx="0" cy="0"/>
+        </a:xfrm>
+      </p:grpSpPr>
+      <p:sp>
+        <p:nvSpPr>
+          <p:cNvPr id="2" name="Title 1"/>
+          <p:cNvSpPr>
+            <a:spLocks noGrp="1"/>
+          </p:cNvSpPr>
+          <p:nvPr>
+            <p:ph type="title"/>
+          </p:nvPr>
+        </p:nvSpPr>
+        <p:spPr/>
+        <p:txBody>
+          <a:bodyPr/>
+          <a:lstStyle/>
+          <a:p>
+            <a:r>
+              <a:rPr lang="en-US" dirty="0" smtClean="0"/>
+              <a:t>Robot Platform: Care-O-</a:t>
+            </a:r>
+            <a:r>
+              <a:rPr lang="en-US" dirty="0" err="1" smtClean="0"/>
+              <a:t>Bot</a:t>
+            </a:r>
+            <a:r>
+              <a:rPr lang="en-US" dirty="0" smtClean="0"/>
+              <a:t> 3</a:t>
+            </a:r>
+            <a:endParaRPr lang="en-US" dirty="0"/>
+          </a:p>
+        </p:txBody>
+      </p:sp>
+      <p:pic>
+        <p:nvPicPr>
+          <p:cNvPr id="4" name="Picture 3" descr="ipa_logo_high_quality_modified.png"/>
+          <p:cNvPicPr>
+            <a:picLocks noChangeAspect="1"/>
+          </p:cNvPicPr>
+          <p:nvPr/>
+        </p:nvPicPr>
+        <p:blipFill>
+          <a:blip r:embed="rId2" cstate="print"/>
+          <a:stretch>
+            <a:fillRect/>
+          </a:stretch>
+        </p:blipFill>
+        <p:spPr>
+          <a:xfrm>
+            <a:off x="7239000" y="76200"/>
+            <a:ext cx="1828800" cy="514567"/>
+          </a:xfrm>
+          <a:prstGeom prst="rect">
+            <a:avLst/>
+          </a:prstGeom>
+        </p:spPr>
+      </p:pic>
+      <p:pic>
+        <p:nvPicPr>
+          <p:cNvPr id="9" name="Content Placeholder 8" descr="cleaning_robot.jpg"/>
+          <p:cNvPicPr>
+            <a:picLocks noGrp="1" noChangeAspect="1"/>
+          </p:cNvPicPr>
+          <p:nvPr>
+            <p:ph idx="1"/>
+          </p:nvPr>
+        </p:nvPicPr>
+        <p:blipFill>
+          <a:blip r:embed="rId3"/>
+          <a:stretch>
+            <a:fillRect/>
+          </a:stretch>
+        </p:blipFill>
+        <p:spPr>
+          <a:xfrm>
+            <a:off x="1524000" y="1905000"/>
+            <a:ext cx="5943600" cy="3966573"/>
+          </a:xfrm>
+        </p:spPr>
+      </p:pic>
+      <p:sp>
+        <p:nvSpPr>
+          <p:cNvPr id="5" name="Slide Number Placeholder 4"/>
+          <p:cNvSpPr>
+            <a:spLocks noGrp="1"/>
+          </p:cNvSpPr>
+          <p:nvPr>
+            <p:ph type="sldNum" sz="quarter" idx="12"/>
+          </p:nvPr>
+        </p:nvSpPr>
+        <p:spPr/>
+        <p:txBody>
+          <a:bodyPr/>
+          <a:lstStyle/>
+          <a:p>
+            <a:fld id="{41F30F6B-FB39-4EE3-BB70-00F6893EC94F}" type="slidenum">
+              <a:rPr lang="en-US" smtClean="0"/>
+              <a:pPr/>
+              <a:t>2</a:t>
+            </a:fld>
+            <a:endParaRPr lang="en-US"/>
+          </a:p>
+        </p:txBody>
+      </p:sp>
+    </p:spTree>
+  </p:cSld>
+  <p:clrMapOvr>
+    <a:masterClrMapping/>
+  </p:clrMapOvr>
+  <p:timing>
+    <p:tnLst>
+      <p:par>
+        <p:cTn id="1" dur="indefinite" restart="never" nodeType="tmRoot"/>
+      </p:par>
+    </p:tnLst>
+  </p:timing>
+</p:sld>
+</file>
+
+<file path=ppt/slides/slide3.xml><?xml version="1.0" encoding="utf-8"?>
+<p:sld xmlns:a="http://schemas.openxmlformats.org/drawingml/2006/main" xmlns:r="http://schemas.openxmlformats.org/officeDocument/2006/relationships" xmlns:p="http://schemas.openxmlformats.org/presentationml/2006/main">
+  <p:cSld>
+    <p:spTree>
+      <p:nvGrpSpPr>
+        <p:cNvPr id="1" name=""/>
+        <p:cNvGrpSpPr/>
+        <p:nvPr/>
+      </p:nvGrpSpPr>
+      <p:grpSpPr>
+        <a:xfrm>
+          <a:off x="0" y="0"/>
+          <a:ext cx="0" cy="0"/>
+          <a:chOff x="0" y="0"/>
+          <a:chExt cx="0" cy="0"/>
+        </a:xfrm>
+      </p:grpSpPr>
+      <p:sp>
+        <p:nvSpPr>
+          <p:cNvPr id="2" name="Title 1"/>
+          <p:cNvSpPr>
+            <a:spLocks noGrp="1"/>
+          </p:cNvSpPr>
+          <p:nvPr>
+            <p:ph type="title"/>
+          </p:nvPr>
+        </p:nvSpPr>
+        <p:spPr/>
+        <p:txBody>
+          <a:bodyPr/>
+          <a:lstStyle/>
+          <a:p>
+            <a:pPr algn="l"/>
+            <a:r>
+              <a:rPr lang="en-US" dirty="0" smtClean="0"/>
+              <a:t>Tasks of Mobile Cleaning Robot:</a:t>
+            </a:r>
+            <a:endParaRPr lang="en-US" dirty="0"/>
+          </a:p>
+        </p:txBody>
+      </p:sp>
+      <p:sp>
+        <p:nvSpPr>
+          <p:cNvPr id="3" name="Content Placeholder 2"/>
+          <p:cNvSpPr>
+            <a:spLocks noGrp="1"/>
+          </p:cNvSpPr>
+          <p:nvPr>
+            <p:ph idx="1"/>
+          </p:nvPr>
+        </p:nvSpPr>
+        <p:spPr/>
+        <p:txBody>
+          <a:bodyPr>
+            <a:normAutofit fontScale="85000" lnSpcReduction="20000"/>
+          </a:bodyPr>
+          <a:lstStyle/>
+          <a:p>
+            <a:r>
+              <a:rPr lang="en-US" dirty="0" smtClean="0"/>
+              <a:t>It will get a office floor plan or any floor plan of any building.</a:t>
+            </a:r>
+          </a:p>
+          <a:p>
+            <a:r>
+              <a:rPr lang="en-US" dirty="0" smtClean="0"/>
+              <a:t>Then it will visit the nearest room from its current position.</a:t>
+            </a:r>
+          </a:p>
+          <a:p>
+            <a:r>
+              <a:rPr lang="en-US" dirty="0" smtClean="0"/>
+              <a:t>During exploration of that room it will detect the dirt and trash bin.</a:t>
+            </a:r>
+          </a:p>
+          <a:p>
+            <a:r>
+              <a:rPr lang="en-US" dirty="0" smtClean="0"/>
+              <a:t>Then it will go to the trash bin position and clear it.</a:t>
+            </a:r>
+          </a:p>
+          <a:p>
+            <a:r>
+              <a:rPr lang="en-US" dirty="0" smtClean="0"/>
+              <a:t>Later it will change the tool to collect dirt by a vacuum cleaner.</a:t>
+            </a:r>
+          </a:p>
+          <a:p>
+            <a:r>
+              <a:rPr lang="en-US" dirty="0" smtClean="0"/>
+              <a:t>Then it will set the room as cleaned and will search for a nearest un-cleaned room.</a:t>
+            </a:r>
+          </a:p>
+          <a:p>
+            <a:endParaRPr lang="en-US" dirty="0"/>
+          </a:p>
+        </p:txBody>
+      </p:sp>
+      <p:pic>
+        <p:nvPicPr>
+          <p:cNvPr id="4" name="Picture 3" descr="ipa_logo_high_quality_modified.png"/>
+          <p:cNvPicPr>
+            <a:picLocks noChangeAspect="1"/>
+          </p:cNvPicPr>
+          <p:nvPr/>
+        </p:nvPicPr>
+        <p:blipFill>
+          <a:blip r:embed="rId2" cstate="print"/>
+          <a:stretch>
+            <a:fillRect/>
+          </a:stretch>
+        </p:blipFill>
+        <p:spPr>
+          <a:xfrm>
+            <a:off x="7239000" y="76200"/>
+            <a:ext cx="1828800" cy="514567"/>
+          </a:xfrm>
+          <a:prstGeom prst="rect">
+            <a:avLst/>
+          </a:prstGeom>
+        </p:spPr>
+      </p:pic>
+      <p:sp>
+        <p:nvSpPr>
+          <p:cNvPr id="5" name="Slide Number Placeholder 4"/>
+          <p:cNvSpPr>
+            <a:spLocks noGrp="1"/>
+          </p:cNvSpPr>
+          <p:nvPr>
+            <p:ph type="sldNum" sz="quarter" idx="12"/>
+          </p:nvPr>
+        </p:nvSpPr>
+        <p:spPr/>
+        <p:txBody>
+          <a:bodyPr/>
+          <a:lstStyle/>
+          <a:p>
+            <a:fld id="{41F30F6B-FB39-4EE3-BB70-00F6893EC94F}" type="slidenum">
+              <a:rPr lang="en-US" smtClean="0"/>
+              <a:pPr/>
+              <a:t>3</a:t>
+            </a:fld>
+            <a:endParaRPr lang="en-US"/>
+          </a:p>
+        </p:txBody>
+      </p:sp>
+    </p:spTree>
+  </p:cSld>
+  <p:clrMapOvr>
+    <a:masterClrMapping/>
+  </p:clrMapOvr>
+  <p:timing>
+    <p:tnLst>
+      <p:par>
+        <p:cTn id="1" dur="indefinite" restart="never" nodeType="tmRoot"/>
+      </p:par>
+    </p:tnLst>
+  </p:timing>
+</p:sld>
+</file>
+
+<file path=ppt/slides/slide4.xml><?xml version="1.0" encoding="utf-8"?>
+<p:sld xmlns:a="http://schemas.openxmlformats.org/drawingml/2006/main" xmlns:r="http://schemas.openxmlformats.org/officeDocument/2006/relationships" xmlns:p="http://schemas.openxmlformats.org/presentationml/2006/main">
+  <p:cSld>
+    <p:spTree>
+      <p:nvGrpSpPr>
+        <p:cNvPr id="1" name=""/>
+        <p:cNvGrpSpPr/>
+        <p:nvPr/>
+      </p:nvGrpSpPr>
+      <p:grpSpPr>
+        <a:xfrm>
+          <a:off x="0" y="0"/>
+          <a:ext cx="0" cy="0"/>
+          <a:chOff x="0" y="0"/>
+          <a:chExt cx="0" cy="0"/>
+        </a:xfrm>
+      </p:grpSpPr>
+      <p:sp>
+        <p:nvSpPr>
+          <p:cNvPr id="2" name="Title 1"/>
+          <p:cNvSpPr>
+            <a:spLocks noGrp="1"/>
+          </p:cNvSpPr>
+          <p:nvPr>
+            <p:ph type="title"/>
+          </p:nvPr>
+        </p:nvSpPr>
+        <p:spPr/>
+        <p:txBody>
+          <a:bodyPr>
+            <a:normAutofit fontScale="90000"/>
+          </a:bodyPr>
+          <a:lstStyle/>
+          <a:p>
+            <a:pPr algn="l"/>
+            <a:r>
+              <a:rPr lang="en-US" dirty="0" smtClean="0"/>
+              <a:t>Main Tasks of Exploration Algorithm:</a:t>
+            </a:r>
+            <a:endParaRPr lang="en-US" dirty="0"/>
+          </a:p>
+        </p:txBody>
+      </p:sp>
+      <p:sp>
+        <p:nvSpPr>
+          <p:cNvPr id="3" name="Content Placeholder 2"/>
+          <p:cNvSpPr>
+            <a:spLocks noGrp="1"/>
+          </p:cNvSpPr>
+          <p:nvPr>
+            <p:ph idx="1"/>
+          </p:nvPr>
+        </p:nvSpPr>
+        <p:spPr/>
+        <p:txBody>
+          <a:bodyPr>
+            <a:normAutofit fontScale="85000" lnSpcReduction="10000"/>
+          </a:bodyPr>
+          <a:lstStyle/>
+          <a:p>
+            <a:r>
+              <a:rPr lang="en-US" dirty="0" smtClean="0"/>
+              <a:t>To explore a office floor or any kind of surface independent of mobile base platform.</a:t>
+            </a:r>
+          </a:p>
+          <a:p>
+            <a:r>
+              <a:rPr lang="en-US" dirty="0" smtClean="0"/>
+              <a:t>Detection of rooms in the floor.</a:t>
+            </a:r>
+          </a:p>
+          <a:p>
+            <a:r>
+              <a:rPr lang="en-US" dirty="0" smtClean="0"/>
+              <a:t>Calculation of the Nearest room location from the base position and command the base to enter into the room</a:t>
+            </a:r>
+          </a:p>
+          <a:p>
+            <a:r>
+              <a:rPr lang="en-US" dirty="0" smtClean="0"/>
+              <a:t>Calculation of accessible areas of the room including dynamic obstacles.</a:t>
+            </a:r>
+          </a:p>
+          <a:p>
+            <a:r>
+              <a:rPr lang="en-US" dirty="0" smtClean="0"/>
+              <a:t>Visit every accessible points. </a:t>
+            </a:r>
+          </a:p>
+          <a:p>
+            <a:r>
+              <a:rPr lang="en-US" dirty="0" smtClean="0"/>
+              <a:t>When finish set the room as processed and search for another unprocessed room.</a:t>
+            </a:r>
+          </a:p>
+        </p:txBody>
+      </p:sp>
+      <p:pic>
+        <p:nvPicPr>
+          <p:cNvPr id="4" name="Picture 3" descr="ipa_logo_high_quality_modified.png"/>
+          <p:cNvPicPr>
+            <a:picLocks noChangeAspect="1"/>
+          </p:cNvPicPr>
+          <p:nvPr/>
+        </p:nvPicPr>
+        <p:blipFill>
+          <a:blip r:embed="rId2" cstate="print"/>
+          <a:stretch>
+            <a:fillRect/>
+          </a:stretch>
+        </p:blipFill>
+        <p:spPr>
+          <a:xfrm>
+            <a:off x="7239000" y="76200"/>
+            <a:ext cx="1828800" cy="514567"/>
+          </a:xfrm>
+          <a:prstGeom prst="rect">
+            <a:avLst/>
+          </a:prstGeom>
+        </p:spPr>
+      </p:pic>
+      <p:sp>
+        <p:nvSpPr>
+          <p:cNvPr id="5" name="Slide Number Placeholder 4"/>
+          <p:cNvSpPr>
+            <a:spLocks noGrp="1"/>
+          </p:cNvSpPr>
+          <p:nvPr>
+            <p:ph type="sldNum" sz="quarter" idx="12"/>
+          </p:nvPr>
+        </p:nvSpPr>
+        <p:spPr/>
+        <p:txBody>
+          <a:bodyPr/>
+          <a:lstStyle/>
+          <a:p>
+            <a:fld id="{41F30F6B-FB39-4EE3-BB70-00F6893EC94F}" type="slidenum">
+              <a:rPr lang="en-US" smtClean="0"/>
+              <a:pPr/>
+              <a:t>4</a:t>
+            </a:fld>
+            <a:endParaRPr lang="en-US"/>
+          </a:p>
+        </p:txBody>
+      </p:sp>
+    </p:spTree>
+  </p:cSld>
+  <p:clrMapOvr>
+    <a:masterClrMapping/>
+  </p:clrMapOvr>
+  <p:timing>
+    <p:tnLst>
+      <p:par>
+        <p:cTn id="1" dur="indefinite" restart="never" nodeType="tmRoot"/>
+      </p:par>
+    </p:tnLst>
+  </p:timing>
+</p:sld>
+</file>
+
+<file path=ppt/slides/slide5.xml><?xml version="1.0" encoding="utf-8"?>
+<p:sld xmlns:a="http://schemas.openxmlformats.org/drawingml/2006/main" xmlns:r="http://schemas.openxmlformats.org/officeDocument/2006/relationships" xmlns:p="http://schemas.openxmlformats.org/presentationml/2006/main">
+  <p:cSld>
+    <p:spTree>
+      <p:nvGrpSpPr>
+        <p:cNvPr id="1" name=""/>
+        <p:cNvGrpSpPr/>
+        <p:nvPr/>
+      </p:nvGrpSpPr>
+      <p:grpSpPr>
+        <a:xfrm>
+          <a:off x="0" y="0"/>
+          <a:ext cx="0" cy="0"/>
+          <a:chOff x="0" y="0"/>
+          <a:chExt cx="0" cy="0"/>
+        </a:xfrm>
+      </p:grpSpPr>
+      <p:sp>
+        <p:nvSpPr>
+          <p:cNvPr id="2" name="Title 1"/>
+          <p:cNvSpPr>
+            <a:spLocks noGrp="1"/>
+          </p:cNvSpPr>
+          <p:nvPr>
+            <p:ph type="title"/>
+          </p:nvPr>
+        </p:nvSpPr>
+        <p:spPr/>
+        <p:txBody>
+          <a:bodyPr/>
+          <a:lstStyle/>
+          <a:p>
+            <a:pPr algn="l"/>
+            <a:r>
+              <a:rPr lang="en-US" dirty="0" smtClean="0"/>
+              <a:t>Why do we need this algorithm?</a:t>
+            </a:r>
+            <a:endParaRPr lang="en-US" dirty="0"/>
+          </a:p>
+        </p:txBody>
+      </p:sp>
+      <p:sp>
+        <p:nvSpPr>
+          <p:cNvPr id="3" name="Content Placeholder 2"/>
+          <p:cNvSpPr>
+            <a:spLocks noGrp="1"/>
+          </p:cNvSpPr>
+          <p:nvPr>
+            <p:ph idx="1"/>
+          </p:nvPr>
+        </p:nvSpPr>
+        <p:spPr/>
+        <p:txBody>
+          <a:bodyPr>
+            <a:normAutofit lnSpcReduction="10000"/>
+          </a:bodyPr>
+          <a:lstStyle/>
+          <a:p>
+            <a:r>
+              <a:rPr lang="en-US" dirty="0" smtClean="0"/>
+              <a:t>Exploration algorithm support dirt detection and trash bin detection during exploration.</a:t>
+            </a:r>
+          </a:p>
+          <a:p>
+            <a:r>
+              <a:rPr lang="en-US" dirty="0" smtClean="0"/>
+              <a:t>It helps the dirt detection algorithm to create a dirt map which </a:t>
+            </a:r>
+            <a:r>
+              <a:rPr lang="en-US" dirty="0" smtClean="0"/>
+              <a:t>is used later </a:t>
+            </a:r>
+            <a:r>
+              <a:rPr lang="en-US" dirty="0" smtClean="0"/>
+              <a:t>to detect dirt during cleaning.</a:t>
+            </a:r>
+          </a:p>
+          <a:p>
+            <a:r>
+              <a:rPr lang="en-US" dirty="0" smtClean="0"/>
+              <a:t> Command the robot a shortest(cost-effective) and suitable path for collecting dirt and cleaning the trash bin based on static and dynamic obstacles.</a:t>
+            </a:r>
+            <a:endParaRPr lang="en-US" dirty="0"/>
+          </a:p>
+        </p:txBody>
+      </p:sp>
+      <p:pic>
+        <p:nvPicPr>
+          <p:cNvPr id="4" name="Picture 3" descr="ipa_logo_high_quality_modified.png"/>
+          <p:cNvPicPr>
+            <a:picLocks noChangeAspect="1"/>
+          </p:cNvPicPr>
+          <p:nvPr/>
+        </p:nvPicPr>
+        <p:blipFill>
+          <a:blip r:embed="rId2" cstate="print"/>
+          <a:stretch>
+            <a:fillRect/>
+          </a:stretch>
+        </p:blipFill>
+        <p:spPr>
+          <a:xfrm>
+            <a:off x="7239000" y="76200"/>
+            <a:ext cx="1828800" cy="514567"/>
+          </a:xfrm>
+          <a:prstGeom prst="rect">
+            <a:avLst/>
+          </a:prstGeom>
+        </p:spPr>
+      </p:pic>
+      <p:sp>
+        <p:nvSpPr>
+          <p:cNvPr id="5" name="Slide Number Placeholder 4"/>
+          <p:cNvSpPr>
+            <a:spLocks noGrp="1"/>
+          </p:cNvSpPr>
+          <p:nvPr>
+            <p:ph type="sldNum" sz="quarter" idx="12"/>
+          </p:nvPr>
+        </p:nvSpPr>
+        <p:spPr/>
+        <p:txBody>
+          <a:bodyPr/>
+          <a:lstStyle/>
+          <a:p>
+            <a:fld id="{41F30F6B-FB39-4EE3-BB70-00F6893EC94F}" type="slidenum">
+              <a:rPr lang="en-US" smtClean="0"/>
+              <a:pPr/>
+              <a:t>5</a:t>
+            </a:fld>
+            <a:endParaRPr lang="en-US"/>
+          </a:p>
+        </p:txBody>
+      </p:sp>
+    </p:spTree>
+  </p:cSld>
+  <p:clrMapOvr>
+    <a:masterClrMapping/>
+  </p:clrMapOvr>
+  <p:timing>
+    <p:tnLst>
+      <p:par>
+        <p:cTn id="1" dur="indefinite" restart="never" nodeType="tmRoot"/>
+      </p:par>
+    </p:tnLst>
+  </p:timing>
+</p:sld>
+</file>
+
+<file path=ppt/slides/slide6.xml><?xml version="1.0" encoding="utf-8"?>
 <p:sld xmlns:a="http://schemas.openxmlformats.org/drawingml/2006/main" xmlns:r="http://schemas.openxmlformats.org/officeDocument/2006/relationships" xmlns:p="http://schemas.openxmlformats.org/presentationml/2006/main">
   <p:cSld>
     <p:spTree>
@@ -4213,7 +5605,7 @@
             <a:fld id="{41F30F6B-FB39-4EE3-BB70-00F6893EC94F}" type="slidenum">
               <a:rPr lang="en-US" smtClean="0"/>
               <a:pPr/>
-              <a:t>13</a:t>
+              <a:t>6</a:t>
             </a:fld>
             <a:endParaRPr lang="en-US"/>
           </a:p>
@@ -4234,7 +5626,7 @@
 </p:sld>
 </file>
 
-<file path=ppt/slides/slide14.xml><?xml version="1.0" encoding="utf-8"?>
+<file path=ppt/slides/slide7.xml><?xml version="1.0" encoding="utf-8"?>
 <p:sld xmlns:a="http://schemas.openxmlformats.org/drawingml/2006/main" xmlns:r="http://schemas.openxmlformats.org/officeDocument/2006/relationships" xmlns:p="http://schemas.openxmlformats.org/presentationml/2006/main">
   <p:cSld>
     <p:spTree>
@@ -4263,161 +5655,97 @@
         </p:nvSpPr>
         <p:spPr/>
         <p:txBody>
+          <a:bodyPr/>
+          <a:lstStyle/>
+          <a:p>
+            <a:r>
+              <a:rPr lang="en-US" dirty="0" smtClean="0"/>
+              <a:t>Map Segmentation Algorithm</a:t>
+            </a:r>
+            <a:endParaRPr lang="en-US" dirty="0"/>
+          </a:p>
+        </p:txBody>
+      </p:sp>
+      <p:sp>
+        <p:nvSpPr>
+          <p:cNvPr id="3" name="Content Placeholder 2"/>
+          <p:cNvSpPr>
+            <a:spLocks noGrp="1"/>
+          </p:cNvSpPr>
+          <p:nvPr>
+            <p:ph idx="1"/>
+          </p:nvPr>
+        </p:nvSpPr>
+        <p:spPr/>
+        <p:txBody>
           <a:bodyPr>
-            <a:normAutofit/>
+            <a:normAutofit fontScale="77500" lnSpcReduction="20000"/>
           </a:bodyPr>
           <a:lstStyle/>
           <a:p>
             <a:r>
               <a:rPr lang="en-US" dirty="0" smtClean="0"/>
-              <a:t>Tasks of Mobile Cleaning Robot:</a:t>
-            </a:r>
+              <a:t>Collect the navigation data from analyze map action client</a:t>
+            </a:r>
+          </a:p>
+          <a:p>
+            <a:r>
+              <a:rPr lang="en-US" dirty="0" smtClean="0"/>
+              <a:t>Erode the image until get the last room</a:t>
+            </a:r>
+          </a:p>
+          <a:p>
+            <a:r>
+              <a:rPr lang="en-US" dirty="0" smtClean="0"/>
+              <a:t>Find contours</a:t>
+            </a:r>
+          </a:p>
+          <a:p>
+            <a:r>
+              <a:rPr lang="en-US" dirty="0" smtClean="0"/>
+              <a:t>For each contour check if contour fulfills criteria of a room</a:t>
+            </a:r>
+          </a:p>
+          <a:p>
+            <a:r>
+              <a:rPr lang="en-US" dirty="0" smtClean="0"/>
+              <a:t>If contour fulfill the criteria save the contour somewhere else</a:t>
+            </a:r>
+          </a:p>
+          <a:p>
+            <a:r>
+              <a:rPr lang="en-US" dirty="0" smtClean="0"/>
+              <a:t>Exit the loop if there are no more contours</a:t>
+            </a:r>
+          </a:p>
+          <a:p>
+            <a:r>
+              <a:rPr lang="en-US" dirty="0" smtClean="0"/>
+              <a:t>Copy original image</a:t>
+            </a:r>
+          </a:p>
+          <a:p>
+            <a:r>
+              <a:rPr lang="en-US" dirty="0" smtClean="0"/>
+              <a:t>Copy the stored contours into the map and fill each with a unique</a:t>
+            </a:r>
+          </a:p>
+          <a:p>
+            <a:r>
+              <a:rPr lang="en-US" dirty="0" smtClean="0"/>
+              <a:t>Id number repeat until convergence(</a:t>
+            </a:r>
+            <a:r>
+              <a:rPr lang="en-US" dirty="0" err="1" smtClean="0"/>
+              <a:t>i.e</a:t>
+            </a:r>
+            <a:r>
+              <a:rPr lang="en-US" dirty="0" smtClean="0"/>
+              <a:t> there are no more white pixels)</a:t>
+            </a:r>
+          </a:p>
+          <a:p>
             <a:endParaRPr lang="en-US" dirty="0"/>
-          </a:p>
-        </p:txBody>
-      </p:sp>
-      <p:pic>
-        <p:nvPicPr>
-          <p:cNvPr id="6" name="Content Placeholder 5" descr="Exploration_Detection_Cleaning.png"/>
-          <p:cNvPicPr>
-            <a:picLocks noGrp="1" noChangeAspect="1"/>
-          </p:cNvPicPr>
-          <p:nvPr>
-            <p:ph idx="1"/>
-          </p:nvPr>
-        </p:nvPicPr>
-        <p:blipFill>
-          <a:blip r:embed="rId2"/>
-          <a:stretch>
-            <a:fillRect/>
-          </a:stretch>
-        </p:blipFill>
-        <p:spPr>
-          <a:xfrm>
-            <a:off x="1066800" y="1371600"/>
-            <a:ext cx="6629400" cy="5334000"/>
-          </a:xfrm>
-        </p:spPr>
-      </p:pic>
-      <p:pic>
-        <p:nvPicPr>
-          <p:cNvPr id="4" name="Picture 3" descr="ipa_logo_high_quality_modified.png"/>
-          <p:cNvPicPr>
-            <a:picLocks noChangeAspect="1"/>
-          </p:cNvPicPr>
-          <p:nvPr/>
-        </p:nvPicPr>
-        <p:blipFill>
-          <a:blip r:embed="rId3" cstate="print"/>
-          <a:stretch>
-            <a:fillRect/>
-          </a:stretch>
-        </p:blipFill>
-        <p:spPr>
-          <a:xfrm>
-            <a:off x="7239000" y="76200"/>
-            <a:ext cx="1828800" cy="514567"/>
-          </a:xfrm>
-          <a:prstGeom prst="rect">
-            <a:avLst/>
-          </a:prstGeom>
-        </p:spPr>
-      </p:pic>
-      <p:sp>
-        <p:nvSpPr>
-          <p:cNvPr id="5" name="Slide Number Placeholder 4"/>
-          <p:cNvSpPr>
-            <a:spLocks noGrp="1"/>
-          </p:cNvSpPr>
-          <p:nvPr>
-            <p:ph type="sldNum" sz="quarter" idx="12"/>
-          </p:nvPr>
-        </p:nvSpPr>
-        <p:spPr/>
-        <p:txBody>
-          <a:bodyPr/>
-          <a:lstStyle/>
-          <a:p>
-            <a:fld id="{41F30F6B-FB39-4EE3-BB70-00F6893EC94F}" type="slidenum">
-              <a:rPr lang="en-US" smtClean="0"/>
-              <a:pPr/>
-              <a:t>14</a:t>
-            </a:fld>
-            <a:endParaRPr lang="en-US"/>
-          </a:p>
-        </p:txBody>
-      </p:sp>
-    </p:spTree>
-  </p:cSld>
-  <p:clrMapOvr>
-    <a:masterClrMapping/>
-  </p:clrMapOvr>
-  <p:timing>
-    <p:tnLst>
-      <p:par>
-        <p:cTn id="1" dur="indefinite" restart="never" nodeType="tmRoot"/>
-      </p:par>
-    </p:tnLst>
-  </p:timing>
-</p:sld>
-</file>
-
-<file path=ppt/slides/slide15.xml><?xml version="1.0" encoding="utf-8"?>
-<p:sld xmlns:a="http://schemas.openxmlformats.org/drawingml/2006/main" xmlns:r="http://schemas.openxmlformats.org/officeDocument/2006/relationships" xmlns:p="http://schemas.openxmlformats.org/presentationml/2006/main">
-  <p:cSld>
-    <p:spTree>
-      <p:nvGrpSpPr>
-        <p:cNvPr id="1" name=""/>
-        <p:cNvGrpSpPr/>
-        <p:nvPr/>
-      </p:nvGrpSpPr>
-      <p:grpSpPr>
-        <a:xfrm>
-          <a:off x="0" y="0"/>
-          <a:ext cx="0" cy="0"/>
-          <a:chOff x="0" y="0"/>
-          <a:chExt cx="0" cy="0"/>
-        </a:xfrm>
-      </p:grpSpPr>
-      <p:sp>
-        <p:nvSpPr>
-          <p:cNvPr id="2" name="Title 1"/>
-          <p:cNvSpPr>
-            <a:spLocks noGrp="1"/>
-          </p:cNvSpPr>
-          <p:nvPr>
-            <p:ph type="title"/>
-          </p:nvPr>
-        </p:nvSpPr>
-        <p:spPr/>
-        <p:txBody>
-          <a:bodyPr/>
-          <a:lstStyle/>
-          <a:p>
-            <a:r>
-              <a:rPr lang="en-US" dirty="0" smtClean="0"/>
-              <a:t>Video of Exploration Algorithm</a:t>
-            </a:r>
-            <a:endParaRPr lang="en-US" dirty="0"/>
-          </a:p>
-        </p:txBody>
-      </p:sp>
-      <p:sp>
-        <p:nvSpPr>
-          <p:cNvPr id="3" name="Content Placeholder 2"/>
-          <p:cNvSpPr>
-            <a:spLocks noGrp="1"/>
-          </p:cNvSpPr>
-          <p:nvPr>
-            <p:ph idx="1"/>
-          </p:nvPr>
-        </p:nvSpPr>
-        <p:spPr/>
-        <p:txBody>
-          <a:bodyPr/>
-          <a:lstStyle/>
-          <a:p>
-            <a:endParaRPr lang="en-US"/>
           </a:p>
         </p:txBody>
       </p:sp>
@@ -4463,7 +5791,7 @@
             <a:fld id="{41F30F6B-FB39-4EE3-BB70-00F6893EC94F}" type="slidenum">
               <a:rPr lang="en-US" smtClean="0"/>
               <a:pPr/>
-              <a:t>15</a:t>
+              <a:t>7</a:t>
             </a:fld>
             <a:endParaRPr lang="en-US"/>
           </a:p>
@@ -4484,1798 +5812,7 @@
 </p:sld>
 </file>
 
-<file path=ppt/slides/slide16.xml><?xml version="1.0" encoding="utf-8"?>
-<p:sld xmlns:a="http://schemas.openxmlformats.org/drawingml/2006/main" xmlns:r="http://schemas.openxmlformats.org/officeDocument/2006/relationships" xmlns:p="http://schemas.openxmlformats.org/presentationml/2006/main">
-  <p:cSld>
-    <p:spTree>
-      <p:nvGrpSpPr>
-        <p:cNvPr id="1" name=""/>
-        <p:cNvGrpSpPr/>
-        <p:nvPr/>
-      </p:nvGrpSpPr>
-      <p:grpSpPr>
-        <a:xfrm>
-          <a:off x="0" y="0"/>
-          <a:ext cx="0" cy="0"/>
-          <a:chOff x="0" y="0"/>
-          <a:chExt cx="0" cy="0"/>
-        </a:xfrm>
-      </p:grpSpPr>
-      <p:sp>
-        <p:nvSpPr>
-          <p:cNvPr id="2" name="Title 1"/>
-          <p:cNvSpPr>
-            <a:spLocks noGrp="1"/>
-          </p:cNvSpPr>
-          <p:nvPr>
-            <p:ph type="title"/>
-          </p:nvPr>
-        </p:nvSpPr>
-        <p:spPr/>
-        <p:txBody>
-          <a:bodyPr/>
-          <a:lstStyle/>
-          <a:p>
-            <a:endParaRPr lang="en-US" dirty="0"/>
-          </a:p>
-        </p:txBody>
-      </p:sp>
-      <p:sp>
-        <p:nvSpPr>
-          <p:cNvPr id="3" name="Content Placeholder 2"/>
-          <p:cNvSpPr>
-            <a:spLocks noGrp="1"/>
-          </p:cNvSpPr>
-          <p:nvPr>
-            <p:ph idx="1"/>
-          </p:nvPr>
-        </p:nvSpPr>
-        <p:spPr/>
-        <p:txBody>
-          <a:bodyPr/>
-          <a:lstStyle/>
-          <a:p>
-            <a:endParaRPr lang="en-US"/>
-          </a:p>
-        </p:txBody>
-      </p:sp>
-      <p:pic>
-        <p:nvPicPr>
-          <p:cNvPr id="4" name="Picture 3" descr="ipa_logo_high_quality_modified.png"/>
-          <p:cNvPicPr>
-            <a:picLocks noChangeAspect="1"/>
-          </p:cNvPicPr>
-          <p:nvPr/>
-        </p:nvPicPr>
-        <p:blipFill>
-          <a:blip r:embed="rId2" cstate="print"/>
-          <a:stretch>
-            <a:fillRect/>
-          </a:stretch>
-        </p:blipFill>
-        <p:spPr>
-          <a:xfrm>
-            <a:off x="7239000" y="76200"/>
-            <a:ext cx="1828800" cy="514567"/>
-          </a:xfrm>
-          <a:prstGeom prst="rect">
-            <a:avLst/>
-          </a:prstGeom>
-        </p:spPr>
-      </p:pic>
-      <p:sp>
-        <p:nvSpPr>
-          <p:cNvPr id="5" name="Slide Number Placeholder 4"/>
-          <p:cNvSpPr>
-            <a:spLocks noGrp="1"/>
-          </p:cNvSpPr>
-          <p:nvPr>
-            <p:ph type="sldNum" sz="quarter" idx="12"/>
-          </p:nvPr>
-        </p:nvSpPr>
-        <p:spPr/>
-        <p:txBody>
-          <a:bodyPr/>
-          <a:lstStyle/>
-          <a:p>
-            <a:fld id="{41F30F6B-FB39-4EE3-BB70-00F6893EC94F}" type="slidenum">
-              <a:rPr lang="en-US" smtClean="0"/>
-              <a:pPr/>
-              <a:t>16</a:t>
-            </a:fld>
-            <a:endParaRPr lang="en-US"/>
-          </a:p>
-        </p:txBody>
-      </p:sp>
-    </p:spTree>
-  </p:cSld>
-  <p:clrMapOvr>
-    <a:masterClrMapping/>
-  </p:clrMapOvr>
-  <p:timing>
-    <p:tnLst>
-      <p:par>
-        <p:cTn id="1" dur="indefinite" restart="never" nodeType="tmRoot"/>
-      </p:par>
-    </p:tnLst>
-  </p:timing>
-</p:sld>
-</file>
-
-<file path=ppt/slides/slide17.xml><?xml version="1.0" encoding="utf-8"?>
-<p:sld xmlns:a="http://schemas.openxmlformats.org/drawingml/2006/main" xmlns:r="http://schemas.openxmlformats.org/officeDocument/2006/relationships" xmlns:p="http://schemas.openxmlformats.org/presentationml/2006/main">
-  <p:cSld>
-    <p:spTree>
-      <p:nvGrpSpPr>
-        <p:cNvPr id="1" name=""/>
-        <p:cNvGrpSpPr/>
-        <p:nvPr/>
-      </p:nvGrpSpPr>
-      <p:grpSpPr>
-        <a:xfrm>
-          <a:off x="0" y="0"/>
-          <a:ext cx="0" cy="0"/>
-          <a:chOff x="0" y="0"/>
-          <a:chExt cx="0" cy="0"/>
-        </a:xfrm>
-      </p:grpSpPr>
-      <p:sp>
-        <p:nvSpPr>
-          <p:cNvPr id="2" name="Title 1"/>
-          <p:cNvSpPr>
-            <a:spLocks noGrp="1"/>
-          </p:cNvSpPr>
-          <p:nvPr>
-            <p:ph type="title"/>
-          </p:nvPr>
-        </p:nvSpPr>
-        <p:spPr/>
-        <p:txBody>
-          <a:bodyPr/>
-          <a:lstStyle/>
-          <a:p>
-            <a:endParaRPr lang="en-US"/>
-          </a:p>
-        </p:txBody>
-      </p:sp>
-      <p:sp>
-        <p:nvSpPr>
-          <p:cNvPr id="3" name="Content Placeholder 2"/>
-          <p:cNvSpPr>
-            <a:spLocks noGrp="1"/>
-          </p:cNvSpPr>
-          <p:nvPr>
-            <p:ph idx="1"/>
-          </p:nvPr>
-        </p:nvSpPr>
-        <p:spPr/>
-        <p:txBody>
-          <a:bodyPr/>
-          <a:lstStyle/>
-          <a:p>
-            <a:endParaRPr lang="en-US"/>
-          </a:p>
-        </p:txBody>
-      </p:sp>
-      <p:pic>
-        <p:nvPicPr>
-          <p:cNvPr id="4" name="Picture 3" descr="ipa_logo_high_quality_modified.png"/>
-          <p:cNvPicPr>
-            <a:picLocks noChangeAspect="1"/>
-          </p:cNvPicPr>
-          <p:nvPr/>
-        </p:nvPicPr>
-        <p:blipFill>
-          <a:blip r:embed="rId2" cstate="print"/>
-          <a:stretch>
-            <a:fillRect/>
-          </a:stretch>
-        </p:blipFill>
-        <p:spPr>
-          <a:xfrm>
-            <a:off x="7239000" y="76200"/>
-            <a:ext cx="1828800" cy="514567"/>
-          </a:xfrm>
-          <a:prstGeom prst="rect">
-            <a:avLst/>
-          </a:prstGeom>
-        </p:spPr>
-      </p:pic>
-      <p:sp>
-        <p:nvSpPr>
-          <p:cNvPr id="5" name="Slide Number Placeholder 4"/>
-          <p:cNvSpPr>
-            <a:spLocks noGrp="1"/>
-          </p:cNvSpPr>
-          <p:nvPr>
-            <p:ph type="sldNum" sz="quarter" idx="12"/>
-          </p:nvPr>
-        </p:nvSpPr>
-        <p:spPr/>
-        <p:txBody>
-          <a:bodyPr/>
-          <a:lstStyle/>
-          <a:p>
-            <a:fld id="{41F30F6B-FB39-4EE3-BB70-00F6893EC94F}" type="slidenum">
-              <a:rPr lang="en-US" smtClean="0"/>
-              <a:pPr/>
-              <a:t>17</a:t>
-            </a:fld>
-            <a:endParaRPr lang="en-US"/>
-          </a:p>
-        </p:txBody>
-      </p:sp>
-    </p:spTree>
-  </p:cSld>
-  <p:clrMapOvr>
-    <a:masterClrMapping/>
-  </p:clrMapOvr>
-  <p:timing>
-    <p:tnLst>
-      <p:par>
-        <p:cTn id="1" dur="indefinite" restart="never" nodeType="tmRoot"/>
-      </p:par>
-    </p:tnLst>
-  </p:timing>
-</p:sld>
-</file>
-
-<file path=ppt/slides/slide18.xml><?xml version="1.0" encoding="utf-8"?>
-<p:sld xmlns:a="http://schemas.openxmlformats.org/drawingml/2006/main" xmlns:r="http://schemas.openxmlformats.org/officeDocument/2006/relationships" xmlns:p="http://schemas.openxmlformats.org/presentationml/2006/main">
-  <p:cSld>
-    <p:spTree>
-      <p:nvGrpSpPr>
-        <p:cNvPr id="1" name=""/>
-        <p:cNvGrpSpPr/>
-        <p:nvPr/>
-      </p:nvGrpSpPr>
-      <p:grpSpPr>
-        <a:xfrm>
-          <a:off x="0" y="0"/>
-          <a:ext cx="0" cy="0"/>
-          <a:chOff x="0" y="0"/>
-          <a:chExt cx="0" cy="0"/>
-        </a:xfrm>
-      </p:grpSpPr>
-      <p:sp>
-        <p:nvSpPr>
-          <p:cNvPr id="2" name="Title 1"/>
-          <p:cNvSpPr>
-            <a:spLocks noGrp="1"/>
-          </p:cNvSpPr>
-          <p:nvPr>
-            <p:ph type="title"/>
-          </p:nvPr>
-        </p:nvSpPr>
-        <p:spPr/>
-        <p:txBody>
-          <a:bodyPr/>
-          <a:lstStyle/>
-          <a:p>
-            <a:endParaRPr lang="en-US"/>
-          </a:p>
-        </p:txBody>
-      </p:sp>
-      <p:sp>
-        <p:nvSpPr>
-          <p:cNvPr id="3" name="Content Placeholder 2"/>
-          <p:cNvSpPr>
-            <a:spLocks noGrp="1"/>
-          </p:cNvSpPr>
-          <p:nvPr>
-            <p:ph idx="1"/>
-          </p:nvPr>
-        </p:nvSpPr>
-        <p:spPr/>
-        <p:txBody>
-          <a:bodyPr/>
-          <a:lstStyle/>
-          <a:p>
-            <a:endParaRPr lang="en-US"/>
-          </a:p>
-        </p:txBody>
-      </p:sp>
-      <p:pic>
-        <p:nvPicPr>
-          <p:cNvPr id="4" name="Picture 3" descr="ipa_logo_high_quality_modified.png"/>
-          <p:cNvPicPr>
-            <a:picLocks noChangeAspect="1"/>
-          </p:cNvPicPr>
-          <p:nvPr/>
-        </p:nvPicPr>
-        <p:blipFill>
-          <a:blip r:embed="rId2" cstate="print"/>
-          <a:stretch>
-            <a:fillRect/>
-          </a:stretch>
-        </p:blipFill>
-        <p:spPr>
-          <a:xfrm>
-            <a:off x="7239000" y="76200"/>
-            <a:ext cx="1828800" cy="514567"/>
-          </a:xfrm>
-          <a:prstGeom prst="rect">
-            <a:avLst/>
-          </a:prstGeom>
-        </p:spPr>
-      </p:pic>
-      <p:sp>
-        <p:nvSpPr>
-          <p:cNvPr id="5" name="Slide Number Placeholder 4"/>
-          <p:cNvSpPr>
-            <a:spLocks noGrp="1"/>
-          </p:cNvSpPr>
-          <p:nvPr>
-            <p:ph type="sldNum" sz="quarter" idx="12"/>
-          </p:nvPr>
-        </p:nvSpPr>
-        <p:spPr/>
-        <p:txBody>
-          <a:bodyPr/>
-          <a:lstStyle/>
-          <a:p>
-            <a:fld id="{41F30F6B-FB39-4EE3-BB70-00F6893EC94F}" type="slidenum">
-              <a:rPr lang="en-US" smtClean="0"/>
-              <a:pPr/>
-              <a:t>18</a:t>
-            </a:fld>
-            <a:endParaRPr lang="en-US"/>
-          </a:p>
-        </p:txBody>
-      </p:sp>
-    </p:spTree>
-  </p:cSld>
-  <p:clrMapOvr>
-    <a:masterClrMapping/>
-  </p:clrMapOvr>
-  <p:timing>
-    <p:tnLst>
-      <p:par>
-        <p:cTn id="1" dur="indefinite" restart="never" nodeType="tmRoot"/>
-      </p:par>
-    </p:tnLst>
-  </p:timing>
-</p:sld>
-</file>
-
-<file path=ppt/slides/slide19.xml><?xml version="1.0" encoding="utf-8"?>
-<p:sld xmlns:a="http://schemas.openxmlformats.org/drawingml/2006/main" xmlns:r="http://schemas.openxmlformats.org/officeDocument/2006/relationships" xmlns:p="http://schemas.openxmlformats.org/presentationml/2006/main">
-  <p:cSld>
-    <p:spTree>
-      <p:nvGrpSpPr>
-        <p:cNvPr id="1" name=""/>
-        <p:cNvGrpSpPr/>
-        <p:nvPr/>
-      </p:nvGrpSpPr>
-      <p:grpSpPr>
-        <a:xfrm>
-          <a:off x="0" y="0"/>
-          <a:ext cx="0" cy="0"/>
-          <a:chOff x="0" y="0"/>
-          <a:chExt cx="0" cy="0"/>
-        </a:xfrm>
-      </p:grpSpPr>
-      <p:sp>
-        <p:nvSpPr>
-          <p:cNvPr id="2" name="Title 1"/>
-          <p:cNvSpPr>
-            <a:spLocks noGrp="1"/>
-          </p:cNvSpPr>
-          <p:nvPr>
-            <p:ph type="title"/>
-          </p:nvPr>
-        </p:nvSpPr>
-        <p:spPr/>
-        <p:txBody>
-          <a:bodyPr/>
-          <a:lstStyle/>
-          <a:p>
-            <a:endParaRPr lang="en-US"/>
-          </a:p>
-        </p:txBody>
-      </p:sp>
-      <p:sp>
-        <p:nvSpPr>
-          <p:cNvPr id="3" name="Content Placeholder 2"/>
-          <p:cNvSpPr>
-            <a:spLocks noGrp="1"/>
-          </p:cNvSpPr>
-          <p:nvPr>
-            <p:ph idx="1"/>
-          </p:nvPr>
-        </p:nvSpPr>
-        <p:spPr/>
-        <p:txBody>
-          <a:bodyPr/>
-          <a:lstStyle/>
-          <a:p>
-            <a:endParaRPr lang="en-US"/>
-          </a:p>
-        </p:txBody>
-      </p:sp>
-      <p:pic>
-        <p:nvPicPr>
-          <p:cNvPr id="4" name="Picture 3" descr="ipa_logo_high_quality_modified.png"/>
-          <p:cNvPicPr>
-            <a:picLocks noChangeAspect="1"/>
-          </p:cNvPicPr>
-          <p:nvPr/>
-        </p:nvPicPr>
-        <p:blipFill>
-          <a:blip r:embed="rId2" cstate="print"/>
-          <a:stretch>
-            <a:fillRect/>
-          </a:stretch>
-        </p:blipFill>
-        <p:spPr>
-          <a:xfrm>
-            <a:off x="7239000" y="76200"/>
-            <a:ext cx="1828800" cy="514567"/>
-          </a:xfrm>
-          <a:prstGeom prst="rect">
-            <a:avLst/>
-          </a:prstGeom>
-        </p:spPr>
-      </p:pic>
-      <p:sp>
-        <p:nvSpPr>
-          <p:cNvPr id="5" name="Slide Number Placeholder 4"/>
-          <p:cNvSpPr>
-            <a:spLocks noGrp="1"/>
-          </p:cNvSpPr>
-          <p:nvPr>
-            <p:ph type="sldNum" sz="quarter" idx="12"/>
-          </p:nvPr>
-        </p:nvSpPr>
-        <p:spPr/>
-        <p:txBody>
-          <a:bodyPr/>
-          <a:lstStyle/>
-          <a:p>
-            <a:fld id="{41F30F6B-FB39-4EE3-BB70-00F6893EC94F}" type="slidenum">
-              <a:rPr lang="en-US" smtClean="0"/>
-              <a:pPr/>
-              <a:t>19</a:t>
-            </a:fld>
-            <a:endParaRPr lang="en-US"/>
-          </a:p>
-        </p:txBody>
-      </p:sp>
-    </p:spTree>
-  </p:cSld>
-  <p:clrMapOvr>
-    <a:masterClrMapping/>
-  </p:clrMapOvr>
-  <p:timing>
-    <p:tnLst>
-      <p:par>
-        <p:cTn id="1" dur="indefinite" restart="never" nodeType="tmRoot"/>
-      </p:par>
-    </p:tnLst>
-  </p:timing>
-</p:sld>
-</file>
-
-<file path=ppt/slides/slide2.xml><?xml version="1.0" encoding="utf-8"?>
-<p:sld xmlns:a="http://schemas.openxmlformats.org/drawingml/2006/main" xmlns:r="http://schemas.openxmlformats.org/officeDocument/2006/relationships" xmlns:p="http://schemas.openxmlformats.org/presentationml/2006/main">
-  <p:cSld>
-    <p:spTree>
-      <p:nvGrpSpPr>
-        <p:cNvPr id="1" name=""/>
-        <p:cNvGrpSpPr/>
-        <p:nvPr/>
-      </p:nvGrpSpPr>
-      <p:grpSpPr>
-        <a:xfrm>
-          <a:off x="0" y="0"/>
-          <a:ext cx="0" cy="0"/>
-          <a:chOff x="0" y="0"/>
-          <a:chExt cx="0" cy="0"/>
-        </a:xfrm>
-      </p:grpSpPr>
-      <p:sp>
-        <p:nvSpPr>
-          <p:cNvPr id="2" name="Title 1"/>
-          <p:cNvSpPr>
-            <a:spLocks noGrp="1"/>
-          </p:cNvSpPr>
-          <p:nvPr>
-            <p:ph type="title"/>
-          </p:nvPr>
-        </p:nvSpPr>
-        <p:spPr/>
-        <p:txBody>
-          <a:bodyPr/>
-          <a:lstStyle/>
-          <a:p>
-            <a:r>
-              <a:rPr lang="en-US" dirty="0" smtClean="0"/>
-              <a:t>Robot Platform: Care-O-</a:t>
-            </a:r>
-            <a:r>
-              <a:rPr lang="en-US" dirty="0" err="1" smtClean="0"/>
-              <a:t>Bot</a:t>
-            </a:r>
-            <a:r>
-              <a:rPr lang="en-US" dirty="0" smtClean="0"/>
-              <a:t> 3</a:t>
-            </a:r>
-            <a:endParaRPr lang="en-US" dirty="0"/>
-          </a:p>
-        </p:txBody>
-      </p:sp>
-      <p:pic>
-        <p:nvPicPr>
-          <p:cNvPr id="4" name="Picture 3" descr="ipa_logo_high_quality_modified.png"/>
-          <p:cNvPicPr>
-            <a:picLocks noChangeAspect="1"/>
-          </p:cNvPicPr>
-          <p:nvPr/>
-        </p:nvPicPr>
-        <p:blipFill>
-          <a:blip r:embed="rId2" cstate="print"/>
-          <a:stretch>
-            <a:fillRect/>
-          </a:stretch>
-        </p:blipFill>
-        <p:spPr>
-          <a:xfrm>
-            <a:off x="7239000" y="76200"/>
-            <a:ext cx="1828800" cy="514567"/>
-          </a:xfrm>
-          <a:prstGeom prst="rect">
-            <a:avLst/>
-          </a:prstGeom>
-        </p:spPr>
-      </p:pic>
-      <p:pic>
-        <p:nvPicPr>
-          <p:cNvPr id="9" name="Content Placeholder 8" descr="cleaning_robot.jpg"/>
-          <p:cNvPicPr>
-            <a:picLocks noGrp="1" noChangeAspect="1"/>
-          </p:cNvPicPr>
-          <p:nvPr>
-            <p:ph idx="1"/>
-          </p:nvPr>
-        </p:nvPicPr>
-        <p:blipFill>
-          <a:blip r:embed="rId3"/>
-          <a:stretch>
-            <a:fillRect/>
-          </a:stretch>
-        </p:blipFill>
-        <p:spPr>
-          <a:xfrm>
-            <a:off x="1524000" y="1905000"/>
-            <a:ext cx="5943600" cy="3966573"/>
-          </a:xfrm>
-        </p:spPr>
-      </p:pic>
-      <p:sp>
-        <p:nvSpPr>
-          <p:cNvPr id="5" name="Slide Number Placeholder 4"/>
-          <p:cNvSpPr>
-            <a:spLocks noGrp="1"/>
-          </p:cNvSpPr>
-          <p:nvPr>
-            <p:ph type="sldNum" sz="quarter" idx="12"/>
-          </p:nvPr>
-        </p:nvSpPr>
-        <p:spPr/>
-        <p:txBody>
-          <a:bodyPr/>
-          <a:lstStyle/>
-          <a:p>
-            <a:fld id="{41F30F6B-FB39-4EE3-BB70-00F6893EC94F}" type="slidenum">
-              <a:rPr lang="en-US" smtClean="0"/>
-              <a:pPr/>
-              <a:t>2</a:t>
-            </a:fld>
-            <a:endParaRPr lang="en-US"/>
-          </a:p>
-        </p:txBody>
-      </p:sp>
-    </p:spTree>
-  </p:cSld>
-  <p:clrMapOvr>
-    <a:masterClrMapping/>
-  </p:clrMapOvr>
-  <p:timing>
-    <p:tnLst>
-      <p:par>
-        <p:cTn id="1" dur="indefinite" restart="never" nodeType="tmRoot"/>
-      </p:par>
-    </p:tnLst>
-  </p:timing>
-</p:sld>
-</file>
-
-<file path=ppt/slides/slide20.xml><?xml version="1.0" encoding="utf-8"?>
-<p:sld xmlns:a="http://schemas.openxmlformats.org/drawingml/2006/main" xmlns:r="http://schemas.openxmlformats.org/officeDocument/2006/relationships" xmlns:p="http://schemas.openxmlformats.org/presentationml/2006/main">
-  <p:cSld>
-    <p:spTree>
-      <p:nvGrpSpPr>
-        <p:cNvPr id="1" name=""/>
-        <p:cNvGrpSpPr/>
-        <p:nvPr/>
-      </p:nvGrpSpPr>
-      <p:grpSpPr>
-        <a:xfrm>
-          <a:off x="0" y="0"/>
-          <a:ext cx="0" cy="0"/>
-          <a:chOff x="0" y="0"/>
-          <a:chExt cx="0" cy="0"/>
-        </a:xfrm>
-      </p:grpSpPr>
-      <p:sp>
-        <p:nvSpPr>
-          <p:cNvPr id="2" name="Title 1"/>
-          <p:cNvSpPr>
-            <a:spLocks noGrp="1"/>
-          </p:cNvSpPr>
-          <p:nvPr>
-            <p:ph type="title"/>
-          </p:nvPr>
-        </p:nvSpPr>
-        <p:spPr/>
-        <p:txBody>
-          <a:bodyPr/>
-          <a:lstStyle/>
-          <a:p>
-            <a:endParaRPr lang="en-US"/>
-          </a:p>
-        </p:txBody>
-      </p:sp>
-      <p:sp>
-        <p:nvSpPr>
-          <p:cNvPr id="3" name="Content Placeholder 2"/>
-          <p:cNvSpPr>
-            <a:spLocks noGrp="1"/>
-          </p:cNvSpPr>
-          <p:nvPr>
-            <p:ph idx="1"/>
-          </p:nvPr>
-        </p:nvSpPr>
-        <p:spPr/>
-        <p:txBody>
-          <a:bodyPr/>
-          <a:lstStyle/>
-          <a:p>
-            <a:endParaRPr lang="en-US"/>
-          </a:p>
-        </p:txBody>
-      </p:sp>
-      <p:pic>
-        <p:nvPicPr>
-          <p:cNvPr id="4" name="Picture 3" descr="ipa_logo_high_quality_modified.png"/>
-          <p:cNvPicPr>
-            <a:picLocks noChangeAspect="1"/>
-          </p:cNvPicPr>
-          <p:nvPr/>
-        </p:nvPicPr>
-        <p:blipFill>
-          <a:blip r:embed="rId2" cstate="print"/>
-          <a:stretch>
-            <a:fillRect/>
-          </a:stretch>
-        </p:blipFill>
-        <p:spPr>
-          <a:xfrm>
-            <a:off x="7239000" y="76200"/>
-            <a:ext cx="1828800" cy="514567"/>
-          </a:xfrm>
-          <a:prstGeom prst="rect">
-            <a:avLst/>
-          </a:prstGeom>
-        </p:spPr>
-      </p:pic>
-      <p:sp>
-        <p:nvSpPr>
-          <p:cNvPr id="5" name="Slide Number Placeholder 4"/>
-          <p:cNvSpPr>
-            <a:spLocks noGrp="1"/>
-          </p:cNvSpPr>
-          <p:nvPr>
-            <p:ph type="sldNum" sz="quarter" idx="12"/>
-          </p:nvPr>
-        </p:nvSpPr>
-        <p:spPr/>
-        <p:txBody>
-          <a:bodyPr/>
-          <a:lstStyle/>
-          <a:p>
-            <a:fld id="{41F30F6B-FB39-4EE3-BB70-00F6893EC94F}" type="slidenum">
-              <a:rPr lang="en-US" smtClean="0"/>
-              <a:pPr/>
-              <a:t>20</a:t>
-            </a:fld>
-            <a:endParaRPr lang="en-US"/>
-          </a:p>
-        </p:txBody>
-      </p:sp>
-    </p:spTree>
-  </p:cSld>
-  <p:clrMapOvr>
-    <a:masterClrMapping/>
-  </p:clrMapOvr>
-  <p:timing>
-    <p:tnLst>
-      <p:par>
-        <p:cTn id="1" dur="indefinite" restart="never" nodeType="tmRoot"/>
-      </p:par>
-    </p:tnLst>
-  </p:timing>
-</p:sld>
-</file>
-
-<file path=ppt/slides/slide21.xml><?xml version="1.0" encoding="utf-8"?>
-<p:sld xmlns:a="http://schemas.openxmlformats.org/drawingml/2006/main" xmlns:r="http://schemas.openxmlformats.org/officeDocument/2006/relationships" xmlns:p="http://schemas.openxmlformats.org/presentationml/2006/main">
-  <p:cSld>
-    <p:spTree>
-      <p:nvGrpSpPr>
-        <p:cNvPr id="1" name=""/>
-        <p:cNvGrpSpPr/>
-        <p:nvPr/>
-      </p:nvGrpSpPr>
-      <p:grpSpPr>
-        <a:xfrm>
-          <a:off x="0" y="0"/>
-          <a:ext cx="0" cy="0"/>
-          <a:chOff x="0" y="0"/>
-          <a:chExt cx="0" cy="0"/>
-        </a:xfrm>
-      </p:grpSpPr>
-      <p:sp>
-        <p:nvSpPr>
-          <p:cNvPr id="2" name="Title 1"/>
-          <p:cNvSpPr>
-            <a:spLocks noGrp="1"/>
-          </p:cNvSpPr>
-          <p:nvPr>
-            <p:ph type="title"/>
-          </p:nvPr>
-        </p:nvSpPr>
-        <p:spPr/>
-        <p:txBody>
-          <a:bodyPr/>
-          <a:lstStyle/>
-          <a:p>
-            <a:endParaRPr lang="en-US"/>
-          </a:p>
-        </p:txBody>
-      </p:sp>
-      <p:sp>
-        <p:nvSpPr>
-          <p:cNvPr id="3" name="Content Placeholder 2"/>
-          <p:cNvSpPr>
-            <a:spLocks noGrp="1"/>
-          </p:cNvSpPr>
-          <p:nvPr>
-            <p:ph idx="1"/>
-          </p:nvPr>
-        </p:nvSpPr>
-        <p:spPr/>
-        <p:txBody>
-          <a:bodyPr/>
-          <a:lstStyle/>
-          <a:p>
-            <a:endParaRPr lang="en-US"/>
-          </a:p>
-        </p:txBody>
-      </p:sp>
-      <p:pic>
-        <p:nvPicPr>
-          <p:cNvPr id="4" name="Picture 3" descr="ipa_logo_high_quality_modified.png"/>
-          <p:cNvPicPr>
-            <a:picLocks noChangeAspect="1"/>
-          </p:cNvPicPr>
-          <p:nvPr/>
-        </p:nvPicPr>
-        <p:blipFill>
-          <a:blip r:embed="rId2" cstate="print"/>
-          <a:stretch>
-            <a:fillRect/>
-          </a:stretch>
-        </p:blipFill>
-        <p:spPr>
-          <a:xfrm>
-            <a:off x="7239000" y="76200"/>
-            <a:ext cx="1828800" cy="514567"/>
-          </a:xfrm>
-          <a:prstGeom prst="rect">
-            <a:avLst/>
-          </a:prstGeom>
-        </p:spPr>
-      </p:pic>
-      <p:sp>
-        <p:nvSpPr>
-          <p:cNvPr id="5" name="Slide Number Placeholder 4"/>
-          <p:cNvSpPr>
-            <a:spLocks noGrp="1"/>
-          </p:cNvSpPr>
-          <p:nvPr>
-            <p:ph type="sldNum" sz="quarter" idx="12"/>
-          </p:nvPr>
-        </p:nvSpPr>
-        <p:spPr/>
-        <p:txBody>
-          <a:bodyPr/>
-          <a:lstStyle/>
-          <a:p>
-            <a:fld id="{41F30F6B-FB39-4EE3-BB70-00F6893EC94F}" type="slidenum">
-              <a:rPr lang="en-US" smtClean="0"/>
-              <a:pPr/>
-              <a:t>21</a:t>
-            </a:fld>
-            <a:endParaRPr lang="en-US"/>
-          </a:p>
-        </p:txBody>
-      </p:sp>
-    </p:spTree>
-  </p:cSld>
-  <p:clrMapOvr>
-    <a:masterClrMapping/>
-  </p:clrMapOvr>
-  <p:timing>
-    <p:tnLst>
-      <p:par>
-        <p:cTn id="1" dur="indefinite" restart="never" nodeType="tmRoot"/>
-      </p:par>
-    </p:tnLst>
-  </p:timing>
-</p:sld>
-</file>
-
-<file path=ppt/slides/slide22.xml><?xml version="1.0" encoding="utf-8"?>
-<p:sld xmlns:a="http://schemas.openxmlformats.org/drawingml/2006/main" xmlns:r="http://schemas.openxmlformats.org/officeDocument/2006/relationships" xmlns:p="http://schemas.openxmlformats.org/presentationml/2006/main">
-  <p:cSld>
-    <p:spTree>
-      <p:nvGrpSpPr>
-        <p:cNvPr id="1" name=""/>
-        <p:cNvGrpSpPr/>
-        <p:nvPr/>
-      </p:nvGrpSpPr>
-      <p:grpSpPr>
-        <a:xfrm>
-          <a:off x="0" y="0"/>
-          <a:ext cx="0" cy="0"/>
-          <a:chOff x="0" y="0"/>
-          <a:chExt cx="0" cy="0"/>
-        </a:xfrm>
-      </p:grpSpPr>
-      <p:sp>
-        <p:nvSpPr>
-          <p:cNvPr id="2" name="Title 1"/>
-          <p:cNvSpPr>
-            <a:spLocks noGrp="1"/>
-          </p:cNvSpPr>
-          <p:nvPr>
-            <p:ph type="title"/>
-          </p:nvPr>
-        </p:nvSpPr>
-        <p:spPr/>
-        <p:txBody>
-          <a:bodyPr/>
-          <a:lstStyle/>
-          <a:p>
-            <a:endParaRPr lang="en-US"/>
-          </a:p>
-        </p:txBody>
-      </p:sp>
-      <p:sp>
-        <p:nvSpPr>
-          <p:cNvPr id="3" name="Content Placeholder 2"/>
-          <p:cNvSpPr>
-            <a:spLocks noGrp="1"/>
-          </p:cNvSpPr>
-          <p:nvPr>
-            <p:ph idx="1"/>
-          </p:nvPr>
-        </p:nvSpPr>
-        <p:spPr/>
-        <p:txBody>
-          <a:bodyPr/>
-          <a:lstStyle/>
-          <a:p>
-            <a:endParaRPr lang="en-US"/>
-          </a:p>
-        </p:txBody>
-      </p:sp>
-      <p:pic>
-        <p:nvPicPr>
-          <p:cNvPr id="4" name="Picture 3" descr="ipa_logo_high_quality_modified.png"/>
-          <p:cNvPicPr>
-            <a:picLocks noChangeAspect="1"/>
-          </p:cNvPicPr>
-          <p:nvPr/>
-        </p:nvPicPr>
-        <p:blipFill>
-          <a:blip r:embed="rId2" cstate="print"/>
-          <a:stretch>
-            <a:fillRect/>
-          </a:stretch>
-        </p:blipFill>
-        <p:spPr>
-          <a:xfrm>
-            <a:off x="7239000" y="76200"/>
-            <a:ext cx="1828800" cy="514567"/>
-          </a:xfrm>
-          <a:prstGeom prst="rect">
-            <a:avLst/>
-          </a:prstGeom>
-        </p:spPr>
-      </p:pic>
-      <p:sp>
-        <p:nvSpPr>
-          <p:cNvPr id="5" name="Slide Number Placeholder 4"/>
-          <p:cNvSpPr>
-            <a:spLocks noGrp="1"/>
-          </p:cNvSpPr>
-          <p:nvPr>
-            <p:ph type="sldNum" sz="quarter" idx="12"/>
-          </p:nvPr>
-        </p:nvSpPr>
-        <p:spPr/>
-        <p:txBody>
-          <a:bodyPr/>
-          <a:lstStyle/>
-          <a:p>
-            <a:fld id="{41F30F6B-FB39-4EE3-BB70-00F6893EC94F}" type="slidenum">
-              <a:rPr lang="en-US" smtClean="0"/>
-              <a:pPr/>
-              <a:t>22</a:t>
-            </a:fld>
-            <a:endParaRPr lang="en-US"/>
-          </a:p>
-        </p:txBody>
-      </p:sp>
-    </p:spTree>
-  </p:cSld>
-  <p:clrMapOvr>
-    <a:masterClrMapping/>
-  </p:clrMapOvr>
-  <p:timing>
-    <p:tnLst>
-      <p:par>
-        <p:cTn id="1" dur="indefinite" restart="never" nodeType="tmRoot"/>
-      </p:par>
-    </p:tnLst>
-  </p:timing>
-</p:sld>
-</file>
-
-<file path=ppt/slides/slide23.xml><?xml version="1.0" encoding="utf-8"?>
-<p:sld xmlns:a="http://schemas.openxmlformats.org/drawingml/2006/main" xmlns:r="http://schemas.openxmlformats.org/officeDocument/2006/relationships" xmlns:p="http://schemas.openxmlformats.org/presentationml/2006/main">
-  <p:cSld>
-    <p:spTree>
-      <p:nvGrpSpPr>
-        <p:cNvPr id="1" name=""/>
-        <p:cNvGrpSpPr/>
-        <p:nvPr/>
-      </p:nvGrpSpPr>
-      <p:grpSpPr>
-        <a:xfrm>
-          <a:off x="0" y="0"/>
-          <a:ext cx="0" cy="0"/>
-          <a:chOff x="0" y="0"/>
-          <a:chExt cx="0" cy="0"/>
-        </a:xfrm>
-      </p:grpSpPr>
-      <p:sp>
-        <p:nvSpPr>
-          <p:cNvPr id="2" name="Title 1"/>
-          <p:cNvSpPr>
-            <a:spLocks noGrp="1"/>
-          </p:cNvSpPr>
-          <p:nvPr>
-            <p:ph type="title"/>
-          </p:nvPr>
-        </p:nvSpPr>
-        <p:spPr/>
-        <p:txBody>
-          <a:bodyPr/>
-          <a:lstStyle/>
-          <a:p>
-            <a:endParaRPr lang="en-US"/>
-          </a:p>
-        </p:txBody>
-      </p:sp>
-      <p:sp>
-        <p:nvSpPr>
-          <p:cNvPr id="3" name="Content Placeholder 2"/>
-          <p:cNvSpPr>
-            <a:spLocks noGrp="1"/>
-          </p:cNvSpPr>
-          <p:nvPr>
-            <p:ph idx="1"/>
-          </p:nvPr>
-        </p:nvSpPr>
-        <p:spPr/>
-        <p:txBody>
-          <a:bodyPr/>
-          <a:lstStyle/>
-          <a:p>
-            <a:endParaRPr lang="en-US"/>
-          </a:p>
-        </p:txBody>
-      </p:sp>
-      <p:pic>
-        <p:nvPicPr>
-          <p:cNvPr id="4" name="Picture 3" descr="ipa_logo_high_quality_modified.png"/>
-          <p:cNvPicPr>
-            <a:picLocks noChangeAspect="1"/>
-          </p:cNvPicPr>
-          <p:nvPr/>
-        </p:nvPicPr>
-        <p:blipFill>
-          <a:blip r:embed="rId2" cstate="print"/>
-          <a:stretch>
-            <a:fillRect/>
-          </a:stretch>
-        </p:blipFill>
-        <p:spPr>
-          <a:xfrm>
-            <a:off x="7239000" y="76200"/>
-            <a:ext cx="1828800" cy="514567"/>
-          </a:xfrm>
-          <a:prstGeom prst="rect">
-            <a:avLst/>
-          </a:prstGeom>
-        </p:spPr>
-      </p:pic>
-      <p:sp>
-        <p:nvSpPr>
-          <p:cNvPr id="5" name="Slide Number Placeholder 4"/>
-          <p:cNvSpPr>
-            <a:spLocks noGrp="1"/>
-          </p:cNvSpPr>
-          <p:nvPr>
-            <p:ph type="sldNum" sz="quarter" idx="12"/>
-          </p:nvPr>
-        </p:nvSpPr>
-        <p:spPr/>
-        <p:txBody>
-          <a:bodyPr/>
-          <a:lstStyle/>
-          <a:p>
-            <a:fld id="{41F30F6B-FB39-4EE3-BB70-00F6893EC94F}" type="slidenum">
-              <a:rPr lang="en-US" smtClean="0"/>
-              <a:pPr/>
-              <a:t>23</a:t>
-            </a:fld>
-            <a:endParaRPr lang="en-US"/>
-          </a:p>
-        </p:txBody>
-      </p:sp>
-    </p:spTree>
-  </p:cSld>
-  <p:clrMapOvr>
-    <a:masterClrMapping/>
-  </p:clrMapOvr>
-  <p:timing>
-    <p:tnLst>
-      <p:par>
-        <p:cTn id="1" dur="indefinite" restart="never" nodeType="tmRoot"/>
-      </p:par>
-    </p:tnLst>
-  </p:timing>
-</p:sld>
-</file>
-
-<file path=ppt/slides/slide3.xml><?xml version="1.0" encoding="utf-8"?>
-<p:sld xmlns:a="http://schemas.openxmlformats.org/drawingml/2006/main" xmlns:r="http://schemas.openxmlformats.org/officeDocument/2006/relationships" xmlns:p="http://schemas.openxmlformats.org/presentationml/2006/main">
-  <p:cSld>
-    <p:spTree>
-      <p:nvGrpSpPr>
-        <p:cNvPr id="1" name=""/>
-        <p:cNvGrpSpPr/>
-        <p:nvPr/>
-      </p:nvGrpSpPr>
-      <p:grpSpPr>
-        <a:xfrm>
-          <a:off x="0" y="0"/>
-          <a:ext cx="0" cy="0"/>
-          <a:chOff x="0" y="0"/>
-          <a:chExt cx="0" cy="0"/>
-        </a:xfrm>
-      </p:grpSpPr>
-      <p:sp>
-        <p:nvSpPr>
-          <p:cNvPr id="2" name="Title 1"/>
-          <p:cNvSpPr>
-            <a:spLocks noGrp="1"/>
-          </p:cNvSpPr>
-          <p:nvPr>
-            <p:ph type="title"/>
-          </p:nvPr>
-        </p:nvSpPr>
-        <p:spPr/>
-        <p:txBody>
-          <a:bodyPr/>
-          <a:lstStyle/>
-          <a:p>
-            <a:pPr algn="l"/>
-            <a:r>
-              <a:rPr lang="en-US" dirty="0" smtClean="0"/>
-              <a:t>Tasks </a:t>
-            </a:r>
-            <a:r>
-              <a:rPr lang="en-US" dirty="0" smtClean="0"/>
-              <a:t>of Mobile Cleaning Robot:</a:t>
-            </a:r>
-            <a:endParaRPr lang="en-US" dirty="0"/>
-          </a:p>
-        </p:txBody>
-      </p:sp>
-      <p:sp>
-        <p:nvSpPr>
-          <p:cNvPr id="3" name="Content Placeholder 2"/>
-          <p:cNvSpPr>
-            <a:spLocks noGrp="1"/>
-          </p:cNvSpPr>
-          <p:nvPr>
-            <p:ph idx="1"/>
-          </p:nvPr>
-        </p:nvSpPr>
-        <p:spPr/>
-        <p:txBody>
-          <a:bodyPr>
-            <a:normAutofit fontScale="85000" lnSpcReduction="20000"/>
-          </a:bodyPr>
-          <a:lstStyle/>
-          <a:p>
-            <a:r>
-              <a:rPr lang="en-US" dirty="0" smtClean="0"/>
-              <a:t>It will get a office floor plan or any floor plan of any building.</a:t>
-            </a:r>
-          </a:p>
-          <a:p>
-            <a:r>
-              <a:rPr lang="en-US" dirty="0" smtClean="0"/>
-              <a:t>Then it will visit the nearest room from its current position.</a:t>
-            </a:r>
-          </a:p>
-          <a:p>
-            <a:r>
-              <a:rPr lang="en-US" dirty="0" smtClean="0"/>
-              <a:t>During exploration of that room it will detect the dirt and trash bin.</a:t>
-            </a:r>
-          </a:p>
-          <a:p>
-            <a:r>
-              <a:rPr lang="en-US" dirty="0" smtClean="0"/>
-              <a:t>Then it will go to the trash bin position and clear it.</a:t>
-            </a:r>
-          </a:p>
-          <a:p>
-            <a:r>
-              <a:rPr lang="en-US" dirty="0" smtClean="0"/>
-              <a:t>Later it will change the tool to collect dirt by a vacuum cleaner.</a:t>
-            </a:r>
-          </a:p>
-          <a:p>
-            <a:r>
-              <a:rPr lang="en-US" dirty="0" smtClean="0"/>
-              <a:t>Then it will set the room as cleaned and will search for a nearest un-cleaned room.</a:t>
-            </a:r>
-          </a:p>
-          <a:p>
-            <a:endParaRPr lang="en-US" dirty="0"/>
-          </a:p>
-        </p:txBody>
-      </p:sp>
-      <p:pic>
-        <p:nvPicPr>
-          <p:cNvPr id="4" name="Picture 3" descr="ipa_logo_high_quality_modified.png"/>
-          <p:cNvPicPr>
-            <a:picLocks noChangeAspect="1"/>
-          </p:cNvPicPr>
-          <p:nvPr/>
-        </p:nvPicPr>
-        <p:blipFill>
-          <a:blip r:embed="rId2" cstate="print"/>
-          <a:stretch>
-            <a:fillRect/>
-          </a:stretch>
-        </p:blipFill>
-        <p:spPr>
-          <a:xfrm>
-            <a:off x="7239000" y="76200"/>
-            <a:ext cx="1828800" cy="514567"/>
-          </a:xfrm>
-          <a:prstGeom prst="rect">
-            <a:avLst/>
-          </a:prstGeom>
-        </p:spPr>
-      </p:pic>
-      <p:sp>
-        <p:nvSpPr>
-          <p:cNvPr id="5" name="Slide Number Placeholder 4"/>
-          <p:cNvSpPr>
-            <a:spLocks noGrp="1"/>
-          </p:cNvSpPr>
-          <p:nvPr>
-            <p:ph type="sldNum" sz="quarter" idx="12"/>
-          </p:nvPr>
-        </p:nvSpPr>
-        <p:spPr/>
-        <p:txBody>
-          <a:bodyPr/>
-          <a:lstStyle/>
-          <a:p>
-            <a:fld id="{41F30F6B-FB39-4EE3-BB70-00F6893EC94F}" type="slidenum">
-              <a:rPr lang="en-US" smtClean="0"/>
-              <a:pPr/>
-              <a:t>3</a:t>
-            </a:fld>
-            <a:endParaRPr lang="en-US"/>
-          </a:p>
-        </p:txBody>
-      </p:sp>
-    </p:spTree>
-  </p:cSld>
-  <p:clrMapOvr>
-    <a:masterClrMapping/>
-  </p:clrMapOvr>
-  <p:timing>
-    <p:tnLst>
-      <p:par>
-        <p:cTn id="1" dur="indefinite" restart="never" nodeType="tmRoot"/>
-      </p:par>
-    </p:tnLst>
-  </p:timing>
-</p:sld>
-</file>
-
-<file path=ppt/slides/slide4.xml><?xml version="1.0" encoding="utf-8"?>
-<p:sld xmlns:a="http://schemas.openxmlformats.org/drawingml/2006/main" xmlns:r="http://schemas.openxmlformats.org/officeDocument/2006/relationships" xmlns:p="http://schemas.openxmlformats.org/presentationml/2006/main">
-  <p:cSld>
-    <p:spTree>
-      <p:nvGrpSpPr>
-        <p:cNvPr id="1" name=""/>
-        <p:cNvGrpSpPr/>
-        <p:nvPr/>
-      </p:nvGrpSpPr>
-      <p:grpSpPr>
-        <a:xfrm>
-          <a:off x="0" y="0"/>
-          <a:ext cx="0" cy="0"/>
-          <a:chOff x="0" y="0"/>
-          <a:chExt cx="0" cy="0"/>
-        </a:xfrm>
-      </p:grpSpPr>
-      <p:sp>
-        <p:nvSpPr>
-          <p:cNvPr id="2" name="Title 1"/>
-          <p:cNvSpPr>
-            <a:spLocks noGrp="1"/>
-          </p:cNvSpPr>
-          <p:nvPr>
-            <p:ph type="title"/>
-          </p:nvPr>
-        </p:nvSpPr>
-        <p:spPr/>
-        <p:txBody>
-          <a:bodyPr>
-            <a:normAutofit fontScale="90000"/>
-          </a:bodyPr>
-          <a:lstStyle/>
-          <a:p>
-            <a:pPr algn="l"/>
-            <a:r>
-              <a:rPr lang="en-US" dirty="0" smtClean="0"/>
-              <a:t>Main </a:t>
-            </a:r>
-            <a:r>
-              <a:rPr lang="en-US" dirty="0" smtClean="0"/>
-              <a:t>Tasks</a:t>
-            </a:r>
-            <a:r>
-              <a:rPr lang="en-US" dirty="0" smtClean="0"/>
-              <a:t> </a:t>
-            </a:r>
-            <a:r>
-              <a:rPr lang="en-US" dirty="0" smtClean="0"/>
-              <a:t>of Exploration Algorithm:</a:t>
-            </a:r>
-            <a:endParaRPr lang="en-US" dirty="0"/>
-          </a:p>
-        </p:txBody>
-      </p:sp>
-      <p:sp>
-        <p:nvSpPr>
-          <p:cNvPr id="3" name="Content Placeholder 2"/>
-          <p:cNvSpPr>
-            <a:spLocks noGrp="1"/>
-          </p:cNvSpPr>
-          <p:nvPr>
-            <p:ph idx="1"/>
-          </p:nvPr>
-        </p:nvSpPr>
-        <p:spPr/>
-        <p:txBody>
-          <a:bodyPr>
-            <a:normAutofit fontScale="85000" lnSpcReduction="10000"/>
-          </a:bodyPr>
-          <a:lstStyle/>
-          <a:p>
-            <a:r>
-              <a:rPr lang="en-US" dirty="0" smtClean="0"/>
-              <a:t>To explore a office floor or any kind of surface independent of mobile base platform.</a:t>
-            </a:r>
-          </a:p>
-          <a:p>
-            <a:r>
-              <a:rPr lang="en-US" dirty="0" smtClean="0"/>
-              <a:t>Detection of rooms in the floor.</a:t>
-            </a:r>
-          </a:p>
-          <a:p>
-            <a:r>
-              <a:rPr lang="en-US" dirty="0" smtClean="0"/>
-              <a:t>Calculation of the Nearest room location from the base position and command the base to enter into the room</a:t>
-            </a:r>
-          </a:p>
-          <a:p>
-            <a:r>
-              <a:rPr lang="en-US" dirty="0" smtClean="0"/>
-              <a:t>Calculation of accessible areas of the room including dynamic obstacles.</a:t>
-            </a:r>
-          </a:p>
-          <a:p>
-            <a:r>
-              <a:rPr lang="en-US" dirty="0" smtClean="0"/>
-              <a:t>Visit every accessible points. </a:t>
-            </a:r>
-          </a:p>
-          <a:p>
-            <a:r>
-              <a:rPr lang="en-US" dirty="0" smtClean="0"/>
-              <a:t>When finish set the room as processed and search for another unprocessed room.</a:t>
-            </a:r>
-          </a:p>
-        </p:txBody>
-      </p:sp>
-      <p:pic>
-        <p:nvPicPr>
-          <p:cNvPr id="4" name="Picture 3" descr="ipa_logo_high_quality_modified.png"/>
-          <p:cNvPicPr>
-            <a:picLocks noChangeAspect="1"/>
-          </p:cNvPicPr>
-          <p:nvPr/>
-        </p:nvPicPr>
-        <p:blipFill>
-          <a:blip r:embed="rId2" cstate="print"/>
-          <a:stretch>
-            <a:fillRect/>
-          </a:stretch>
-        </p:blipFill>
-        <p:spPr>
-          <a:xfrm>
-            <a:off x="7239000" y="76200"/>
-            <a:ext cx="1828800" cy="514567"/>
-          </a:xfrm>
-          <a:prstGeom prst="rect">
-            <a:avLst/>
-          </a:prstGeom>
-        </p:spPr>
-      </p:pic>
-      <p:sp>
-        <p:nvSpPr>
-          <p:cNvPr id="5" name="Slide Number Placeholder 4"/>
-          <p:cNvSpPr>
-            <a:spLocks noGrp="1"/>
-          </p:cNvSpPr>
-          <p:nvPr>
-            <p:ph type="sldNum" sz="quarter" idx="12"/>
-          </p:nvPr>
-        </p:nvSpPr>
-        <p:spPr/>
-        <p:txBody>
-          <a:bodyPr/>
-          <a:lstStyle/>
-          <a:p>
-            <a:fld id="{41F30F6B-FB39-4EE3-BB70-00F6893EC94F}" type="slidenum">
-              <a:rPr lang="en-US" smtClean="0"/>
-              <a:pPr/>
-              <a:t>4</a:t>
-            </a:fld>
-            <a:endParaRPr lang="en-US"/>
-          </a:p>
-        </p:txBody>
-      </p:sp>
-    </p:spTree>
-  </p:cSld>
-  <p:clrMapOvr>
-    <a:masterClrMapping/>
-  </p:clrMapOvr>
-  <p:timing>
-    <p:tnLst>
-      <p:par>
-        <p:cTn id="1" dur="indefinite" restart="never" nodeType="tmRoot"/>
-      </p:par>
-    </p:tnLst>
-  </p:timing>
-</p:sld>
-</file>
-
-<file path=ppt/slides/slide5.xml><?xml version="1.0" encoding="utf-8"?>
-<p:sld xmlns:a="http://schemas.openxmlformats.org/drawingml/2006/main" xmlns:r="http://schemas.openxmlformats.org/officeDocument/2006/relationships" xmlns:p="http://schemas.openxmlformats.org/presentationml/2006/main">
-  <p:cSld>
-    <p:spTree>
-      <p:nvGrpSpPr>
-        <p:cNvPr id="1" name=""/>
-        <p:cNvGrpSpPr/>
-        <p:nvPr/>
-      </p:nvGrpSpPr>
-      <p:grpSpPr>
-        <a:xfrm>
-          <a:off x="0" y="0"/>
-          <a:ext cx="0" cy="0"/>
-          <a:chOff x="0" y="0"/>
-          <a:chExt cx="0" cy="0"/>
-        </a:xfrm>
-      </p:grpSpPr>
-      <p:sp>
-        <p:nvSpPr>
-          <p:cNvPr id="2" name="Title 1"/>
-          <p:cNvSpPr>
-            <a:spLocks noGrp="1"/>
-          </p:cNvSpPr>
-          <p:nvPr>
-            <p:ph type="title"/>
-          </p:nvPr>
-        </p:nvSpPr>
-        <p:spPr/>
-        <p:txBody>
-          <a:bodyPr/>
-          <a:lstStyle/>
-          <a:p>
-            <a:pPr algn="l"/>
-            <a:r>
-              <a:rPr lang="en-US" dirty="0" smtClean="0"/>
-              <a:t>Why do we need this algorithm?</a:t>
-            </a:r>
-            <a:endParaRPr lang="en-US" dirty="0"/>
-          </a:p>
-        </p:txBody>
-      </p:sp>
-      <p:sp>
-        <p:nvSpPr>
-          <p:cNvPr id="3" name="Content Placeholder 2"/>
-          <p:cNvSpPr>
-            <a:spLocks noGrp="1"/>
-          </p:cNvSpPr>
-          <p:nvPr>
-            <p:ph idx="1"/>
-          </p:nvPr>
-        </p:nvSpPr>
-        <p:spPr/>
-        <p:txBody>
-          <a:bodyPr>
-            <a:normAutofit lnSpcReduction="10000"/>
-          </a:bodyPr>
-          <a:lstStyle/>
-          <a:p>
-            <a:r>
-              <a:rPr lang="en-US" dirty="0" smtClean="0"/>
-              <a:t>Exploration algorithm support dirt detection and trash bin detection during exploration.</a:t>
-            </a:r>
-          </a:p>
-          <a:p>
-            <a:r>
-              <a:rPr lang="en-US" dirty="0" smtClean="0"/>
-              <a:t>It helps the dirt detection algorithm to create a dirt </a:t>
-            </a:r>
-            <a:r>
-              <a:rPr lang="en-US" dirty="0" smtClean="0"/>
-              <a:t>map which later is used to detect dirt during cleaning.</a:t>
-            </a:r>
-            <a:endParaRPr lang="en-US" dirty="0" smtClean="0"/>
-          </a:p>
-          <a:p>
-            <a:r>
-              <a:rPr lang="en-US" dirty="0" smtClean="0"/>
-              <a:t> Command the robot a shortest(cost-effective) and suitable path for collecting dirt and cleaning the trash bin based on static and dynamic obstacles.</a:t>
-            </a:r>
-            <a:endParaRPr lang="en-US" dirty="0"/>
-          </a:p>
-        </p:txBody>
-      </p:sp>
-      <p:pic>
-        <p:nvPicPr>
-          <p:cNvPr id="4" name="Picture 3" descr="ipa_logo_high_quality_modified.png"/>
-          <p:cNvPicPr>
-            <a:picLocks noChangeAspect="1"/>
-          </p:cNvPicPr>
-          <p:nvPr/>
-        </p:nvPicPr>
-        <p:blipFill>
-          <a:blip r:embed="rId2" cstate="print"/>
-          <a:stretch>
-            <a:fillRect/>
-          </a:stretch>
-        </p:blipFill>
-        <p:spPr>
-          <a:xfrm>
-            <a:off x="7239000" y="76200"/>
-            <a:ext cx="1828800" cy="514567"/>
-          </a:xfrm>
-          <a:prstGeom prst="rect">
-            <a:avLst/>
-          </a:prstGeom>
-        </p:spPr>
-      </p:pic>
-      <p:sp>
-        <p:nvSpPr>
-          <p:cNvPr id="5" name="Slide Number Placeholder 4"/>
-          <p:cNvSpPr>
-            <a:spLocks noGrp="1"/>
-          </p:cNvSpPr>
-          <p:nvPr>
-            <p:ph type="sldNum" sz="quarter" idx="12"/>
-          </p:nvPr>
-        </p:nvSpPr>
-        <p:spPr/>
-        <p:txBody>
-          <a:bodyPr/>
-          <a:lstStyle/>
-          <a:p>
-            <a:fld id="{41F30F6B-FB39-4EE3-BB70-00F6893EC94F}" type="slidenum">
-              <a:rPr lang="en-US" smtClean="0"/>
-              <a:pPr/>
-              <a:t>5</a:t>
-            </a:fld>
-            <a:endParaRPr lang="en-US"/>
-          </a:p>
-        </p:txBody>
-      </p:sp>
-    </p:spTree>
-  </p:cSld>
-  <p:clrMapOvr>
-    <a:masterClrMapping/>
-  </p:clrMapOvr>
-  <p:timing>
-    <p:tnLst>
-      <p:par>
-        <p:cTn id="1" dur="indefinite" restart="never" nodeType="tmRoot"/>
-      </p:par>
-    </p:tnLst>
-  </p:timing>
-</p:sld>
-</file>
-
-<file path=ppt/slides/slide6.xml><?xml version="1.0" encoding="utf-8"?>
-<p:sld xmlns:a="http://schemas.openxmlformats.org/drawingml/2006/main" xmlns:r="http://schemas.openxmlformats.org/officeDocument/2006/relationships" xmlns:p="http://schemas.openxmlformats.org/presentationml/2006/main">
-  <p:cSld>
-    <p:spTree>
-      <p:nvGrpSpPr>
-        <p:cNvPr id="1" name=""/>
-        <p:cNvGrpSpPr/>
-        <p:nvPr/>
-      </p:nvGrpSpPr>
-      <p:grpSpPr>
-        <a:xfrm>
-          <a:off x="0" y="0"/>
-          <a:ext cx="0" cy="0"/>
-          <a:chOff x="0" y="0"/>
-          <a:chExt cx="0" cy="0"/>
-        </a:xfrm>
-      </p:grpSpPr>
-      <p:sp>
-        <p:nvSpPr>
-          <p:cNvPr id="2" name="Title 1"/>
-          <p:cNvSpPr>
-            <a:spLocks noGrp="1"/>
-          </p:cNvSpPr>
-          <p:nvPr>
-            <p:ph type="title"/>
-          </p:nvPr>
-        </p:nvSpPr>
-        <p:spPr/>
-        <p:txBody>
-          <a:bodyPr/>
-          <a:lstStyle/>
-          <a:p>
-            <a:r>
-              <a:rPr lang="en-US" dirty="0" smtClean="0"/>
-              <a:t>Analyze Floor Plan</a:t>
-            </a:r>
-            <a:endParaRPr lang="en-US" dirty="0"/>
-          </a:p>
-        </p:txBody>
-      </p:sp>
-      <p:sp>
-        <p:nvSpPr>
-          <p:cNvPr id="3" name="Content Placeholder 2"/>
-          <p:cNvSpPr>
-            <a:spLocks noGrp="1"/>
-          </p:cNvSpPr>
-          <p:nvPr>
-            <p:ph idx="1"/>
-          </p:nvPr>
-        </p:nvSpPr>
-        <p:spPr/>
-        <p:txBody>
-          <a:bodyPr>
-            <a:normAutofit fontScale="77500" lnSpcReduction="20000"/>
-          </a:bodyPr>
-          <a:lstStyle/>
-          <a:p>
-            <a:r>
-              <a:rPr lang="en-US" dirty="0" smtClean="0"/>
-              <a:t>C</a:t>
-            </a:r>
-            <a:r>
-              <a:rPr lang="en-US" dirty="0" smtClean="0"/>
-              <a:t>ollect </a:t>
-            </a:r>
-            <a:r>
-              <a:rPr lang="en-US" dirty="0" smtClean="0"/>
-              <a:t>the navigation data from analyze map action client</a:t>
-            </a:r>
-          </a:p>
-          <a:p>
-            <a:r>
-              <a:rPr lang="en-US" dirty="0" smtClean="0"/>
-              <a:t>E</a:t>
-            </a:r>
-            <a:r>
-              <a:rPr lang="en-US" dirty="0" smtClean="0"/>
-              <a:t>rode </a:t>
-            </a:r>
-            <a:r>
-              <a:rPr lang="en-US" dirty="0" smtClean="0"/>
-              <a:t>the image until get the last room</a:t>
-            </a:r>
-          </a:p>
-          <a:p>
-            <a:r>
-              <a:rPr lang="en-US" dirty="0" smtClean="0"/>
-              <a:t>Find </a:t>
-            </a:r>
-            <a:r>
-              <a:rPr lang="en-US" dirty="0" smtClean="0"/>
-              <a:t>contours</a:t>
-            </a:r>
-          </a:p>
-          <a:p>
-            <a:r>
-              <a:rPr lang="en-US" dirty="0" smtClean="0"/>
-              <a:t>For </a:t>
-            </a:r>
-            <a:r>
-              <a:rPr lang="en-US" dirty="0" smtClean="0"/>
-              <a:t>each contour check if contour fulfills criteria of a room</a:t>
-            </a:r>
-          </a:p>
-          <a:p>
-            <a:r>
-              <a:rPr lang="en-US" dirty="0" smtClean="0"/>
-              <a:t>If </a:t>
-            </a:r>
-            <a:r>
-              <a:rPr lang="en-US" dirty="0" smtClean="0"/>
-              <a:t>contour fulfill the criteria save the contour somewhere else</a:t>
-            </a:r>
-          </a:p>
-          <a:p>
-            <a:r>
-              <a:rPr lang="en-US" dirty="0" smtClean="0"/>
-              <a:t>Exit </a:t>
-            </a:r>
-            <a:r>
-              <a:rPr lang="en-US" dirty="0" smtClean="0"/>
-              <a:t>the loop if there are no more contours</a:t>
-            </a:r>
-          </a:p>
-          <a:p>
-            <a:r>
-              <a:rPr lang="en-US" dirty="0" smtClean="0"/>
-              <a:t>Copy </a:t>
-            </a:r>
-            <a:r>
-              <a:rPr lang="en-US" dirty="0" smtClean="0"/>
-              <a:t>original image</a:t>
-            </a:r>
-          </a:p>
-          <a:p>
-            <a:r>
-              <a:rPr lang="en-US" dirty="0" smtClean="0"/>
-              <a:t>Copy </a:t>
-            </a:r>
-            <a:r>
-              <a:rPr lang="en-US" dirty="0" smtClean="0"/>
-              <a:t>the stored contours into the map and fill each with a unique</a:t>
-            </a:r>
-          </a:p>
-          <a:p>
-            <a:r>
-              <a:rPr lang="en-US" dirty="0" smtClean="0"/>
-              <a:t>Id </a:t>
-            </a:r>
-            <a:r>
-              <a:rPr lang="en-US" dirty="0" smtClean="0"/>
-              <a:t>number repeat until convergence(</a:t>
-            </a:r>
-            <a:r>
-              <a:rPr lang="en-US" dirty="0" err="1" smtClean="0"/>
-              <a:t>i.e</a:t>
-            </a:r>
-            <a:r>
-              <a:rPr lang="en-US" dirty="0" smtClean="0"/>
-              <a:t> there are no more white pixels)</a:t>
-            </a:r>
-          </a:p>
-          <a:p>
-            <a:endParaRPr lang="en-US" dirty="0"/>
-          </a:p>
-        </p:txBody>
-      </p:sp>
-      <p:pic>
-        <p:nvPicPr>
-          <p:cNvPr id="4" name="Picture 3" descr="ipa_logo_high_quality_modified.png"/>
-          <p:cNvPicPr>
-            <a:picLocks noChangeAspect="1"/>
-          </p:cNvPicPr>
-          <p:nvPr/>
-        </p:nvPicPr>
-        <p:blipFill>
-          <a:blip r:embed="rId2" cstate="print"/>
-          <a:stretch>
-            <a:fillRect/>
-          </a:stretch>
-        </p:blipFill>
-        <p:spPr>
-          <a:xfrm>
-            <a:off x="7239000" y="76200"/>
-            <a:ext cx="1828800" cy="514567"/>
-          </a:xfrm>
-          <a:prstGeom prst="rect">
-            <a:avLst/>
-          </a:prstGeom>
-        </p:spPr>
-      </p:pic>
-      <p:sp>
-        <p:nvSpPr>
-          <p:cNvPr id="5" name="Slide Number Placeholder 4"/>
-          <p:cNvSpPr>
-            <a:spLocks noGrp="1"/>
-          </p:cNvSpPr>
-          <p:nvPr>
-            <p:ph type="sldNum" sz="quarter" idx="12"/>
-          </p:nvPr>
-        </p:nvSpPr>
-        <p:spPr/>
-        <p:txBody>
-          <a:bodyPr/>
-          <a:lstStyle/>
-          <a:p>
-            <a:fld id="{41F30F6B-FB39-4EE3-BB70-00F6893EC94F}" type="slidenum">
-              <a:rPr lang="en-US" smtClean="0"/>
-              <a:pPr/>
-              <a:t>6</a:t>
-            </a:fld>
-            <a:endParaRPr lang="en-US"/>
-          </a:p>
-        </p:txBody>
-      </p:sp>
-    </p:spTree>
-  </p:cSld>
-  <p:clrMapOvr>
-    <a:masterClrMapping/>
-  </p:clrMapOvr>
-  <p:timing>
-    <p:tnLst>
-      <p:par>
-        <p:cTn id="1" dur="indefinite" restart="never" nodeType="tmRoot"/>
-      </p:par>
-    </p:tnLst>
-  </p:timing>
-</p:sld>
-</file>
-
-<file path=ppt/slides/slide7.xml><?xml version="1.0" encoding="utf-8"?>
+<file path=ppt/slides/slide8.xml><?xml version="1.0" encoding="utf-8"?>
 <p:sld xmlns:a="http://schemas.openxmlformats.org/drawingml/2006/main" xmlns:r="http://schemas.openxmlformats.org/officeDocument/2006/relationships" xmlns:p="http://schemas.openxmlformats.org/presentationml/2006/main">
   <p:cSld>
     <p:spTree>
@@ -6380,132 +5917,6 @@
             <a:fld id="{41F30F6B-FB39-4EE3-BB70-00F6893EC94F}" type="slidenum">
               <a:rPr lang="en-US" smtClean="0"/>
               <a:pPr/>
-              <a:t>7</a:t>
-            </a:fld>
-            <a:endParaRPr lang="en-US"/>
-          </a:p>
-        </p:txBody>
-      </p:sp>
-    </p:spTree>
-  </p:cSld>
-  <p:clrMapOvr>
-    <a:masterClrMapping/>
-  </p:clrMapOvr>
-  <p:timing>
-    <p:tnLst>
-      <p:par>
-        <p:cTn id="1" dur="indefinite" restart="never" nodeType="tmRoot"/>
-      </p:par>
-    </p:tnLst>
-  </p:timing>
-</p:sld>
-</file>
-
-<file path=ppt/slides/slide8.xml><?xml version="1.0" encoding="utf-8"?>
-<p:sld xmlns:a="http://schemas.openxmlformats.org/drawingml/2006/main" xmlns:r="http://schemas.openxmlformats.org/officeDocument/2006/relationships" xmlns:p="http://schemas.openxmlformats.org/presentationml/2006/main">
-  <p:cSld>
-    <p:spTree>
-      <p:nvGrpSpPr>
-        <p:cNvPr id="1" name=""/>
-        <p:cNvGrpSpPr/>
-        <p:nvPr/>
-      </p:nvGrpSpPr>
-      <p:grpSpPr>
-        <a:xfrm>
-          <a:off x="0" y="0"/>
-          <a:ext cx="0" cy="0"/>
-          <a:chOff x="0" y="0"/>
-          <a:chExt cx="0" cy="0"/>
-        </a:xfrm>
-      </p:grpSpPr>
-      <p:sp>
-        <p:nvSpPr>
-          <p:cNvPr id="2" name="Title 1"/>
-          <p:cNvSpPr>
-            <a:spLocks noGrp="1"/>
-          </p:cNvSpPr>
-          <p:nvPr>
-            <p:ph type="title"/>
-          </p:nvPr>
-        </p:nvSpPr>
-        <p:spPr/>
-        <p:txBody>
-          <a:bodyPr/>
-          <a:lstStyle/>
-          <a:p>
-            <a:r>
-              <a:rPr lang="en-US" dirty="0" smtClean="0"/>
-              <a:t>Analyze Floor Plan</a:t>
-            </a:r>
-            <a:endParaRPr lang="en-US" dirty="0"/>
-          </a:p>
-        </p:txBody>
-      </p:sp>
-      <p:pic>
-        <p:nvPicPr>
-          <p:cNvPr id="6" name="Content Placeholder 5" descr="during_iteration_process.png"/>
-          <p:cNvPicPr>
-            <a:picLocks noGrp="1" noChangeAspect="1"/>
-          </p:cNvPicPr>
-          <p:nvPr>
-            <p:ph idx="1"/>
-          </p:nvPr>
-        </p:nvPicPr>
-        <p:blipFill>
-          <a:blip r:embed="rId2"/>
-          <a:stretch>
-            <a:fillRect/>
-          </a:stretch>
-        </p:blipFill>
-        <p:spPr>
-          <a:xfrm>
-            <a:off x="1905000" y="1295400"/>
-            <a:ext cx="5486400" cy="5183683"/>
-          </a:xfrm>
-        </p:spPr>
-      </p:pic>
-      <p:pic>
-        <p:nvPicPr>
-          <p:cNvPr id="4" name="Picture 3" descr="ipa_logo_high_quality_modified.png"/>
-          <p:cNvPicPr>
-            <a:picLocks noChangeAspect="1"/>
-          </p:cNvPicPr>
-          <p:nvPr/>
-        </p:nvPicPr>
-        <p:blipFill>
-          <a:blip r:embed="rId3" cstate="print"/>
-          <a:stretch>
-            <a:fillRect/>
-          </a:stretch>
-        </p:blipFill>
-        <p:spPr>
-          <a:xfrm>
-            <a:off x="7239000" y="76200"/>
-            <a:ext cx="1828800" cy="514567"/>
-          </a:xfrm>
-          <a:prstGeom prst="rect">
-            <a:avLst/>
-          </a:prstGeom>
-        </p:spPr>
-      </p:pic>
-      <p:sp>
-        <p:nvSpPr>
-          <p:cNvPr id="5" name="Slide Number Placeholder 4"/>
-          <p:cNvSpPr>
-            <a:spLocks noGrp="1"/>
-          </p:cNvSpPr>
-          <p:nvPr>
-            <p:ph type="sldNum" sz="quarter" idx="12"/>
-          </p:nvPr>
-        </p:nvSpPr>
-        <p:spPr/>
-        <p:txBody>
-          <a:bodyPr/>
-          <a:lstStyle/>
-          <a:p>
-            <a:fld id="{41F30F6B-FB39-4EE3-BB70-00F6893EC94F}" type="slidenum">
-              <a:rPr lang="en-US" smtClean="0"/>
-              <a:pPr/>
               <a:t>8</a:t>
             </a:fld>
             <a:endParaRPr lang="en-US"/>
@@ -6569,7 +5980,7 @@
       </p:sp>
       <p:pic>
         <p:nvPicPr>
-          <p:cNvPr id="6" name="Content Placeholder 5" descr="segmented_map_of_IPA.png"/>
+          <p:cNvPr id="6" name="Content Placeholder 5" descr="during_iteration_process.png"/>
           <p:cNvPicPr>
             <a:picLocks noGrp="1" noChangeAspect="1"/>
           </p:cNvPicPr>
@@ -6585,8 +5996,8 @@
         </p:blipFill>
         <p:spPr>
           <a:xfrm>
-            <a:off x="1981200" y="1447800"/>
-            <a:ext cx="5346215" cy="5029200"/>
+            <a:off x="1905000" y="1295400"/>
+            <a:ext cx="5486400" cy="5183683"/>
           </a:xfrm>
         </p:spPr>
       </p:pic>

</xml_diff>

<commit_message>
Presentation Slide is complete now
</commit_message>
<xml_diff>
--- a/Presentation/Presentation_Slide.pptx
+++ b/Presentation/Presentation_Slide.pptx
@@ -5,7 +5,7 @@
     <p:sldMasterId id="2147483648" r:id="rId1"/>
   </p:sldMasterIdLst>
   <p:notesMasterIdLst>
-    <p:notesMasterId r:id="rId19"/>
+    <p:notesMasterId r:id="rId20"/>
   </p:notesMasterIdLst>
   <p:sldIdLst>
     <p:sldId id="256" r:id="rId2"/>
@@ -22,9 +22,10 @@
     <p:sldId id="263" r:id="rId13"/>
     <p:sldId id="264" r:id="rId14"/>
     <p:sldId id="266" r:id="rId15"/>
-    <p:sldId id="267" r:id="rId16"/>
-    <p:sldId id="268" r:id="rId17"/>
-    <p:sldId id="283" r:id="rId18"/>
+    <p:sldId id="286" r:id="rId16"/>
+    <p:sldId id="267" r:id="rId17"/>
+    <p:sldId id="268" r:id="rId18"/>
+    <p:sldId id="283" r:id="rId19"/>
   </p:sldIdLst>
   <p:sldSz cx="9144000" cy="6858000" type="screen4x3"/>
   <p:notesSz cx="6858000" cy="9144000"/>
@@ -209,7 +210,7 @@
             <a:fld id="{D1A485A5-056C-4DE1-B938-B7BB4CEE4326}" type="datetimeFigureOut">
               <a:rPr lang="en-US" smtClean="0"/>
               <a:pPr/>
-              <a:t>28/09/2013</a:t>
+              <a:t>29/09/2013</a:t>
             </a:fld>
             <a:endParaRPr lang="en-US"/>
           </a:p>
@@ -821,7 +822,7 @@
             <a:fld id="{E5011768-7637-4D51-85C0-F985CC0D3053}" type="datetime1">
               <a:rPr lang="en-US" smtClean="0"/>
               <a:pPr/>
-              <a:t>28/09/2013</a:t>
+              <a:t>29/09/2013</a:t>
             </a:fld>
             <a:endParaRPr lang="en-US"/>
           </a:p>
@@ -988,7 +989,7 @@
             <a:fld id="{A6695160-AD22-4B29-B338-A2FA883490CB}" type="datetime1">
               <a:rPr lang="en-US" smtClean="0"/>
               <a:pPr/>
-              <a:t>28/09/2013</a:t>
+              <a:t>29/09/2013</a:t>
             </a:fld>
             <a:endParaRPr lang="en-US"/>
           </a:p>
@@ -1165,7 +1166,7 @@
             <a:fld id="{5FD137B7-8E35-4086-B14F-D22793E929BA}" type="datetime1">
               <a:rPr lang="en-US" smtClean="0"/>
               <a:pPr/>
-              <a:t>28/09/2013</a:t>
+              <a:t>29/09/2013</a:t>
             </a:fld>
             <a:endParaRPr lang="en-US"/>
           </a:p>
@@ -1332,7 +1333,7 @@
             <a:fld id="{03DACB65-7EC6-4BB4-A341-FB78540C5188}" type="datetime1">
               <a:rPr lang="en-US" smtClean="0"/>
               <a:pPr/>
-              <a:t>28/09/2013</a:t>
+              <a:t>29/09/2013</a:t>
             </a:fld>
             <a:endParaRPr lang="en-US"/>
           </a:p>
@@ -1575,7 +1576,7 @@
             <a:fld id="{E8D044E0-1753-44D3-AF1F-E461CA2580F0}" type="datetime1">
               <a:rPr lang="en-US" smtClean="0"/>
               <a:pPr/>
-              <a:t>28/09/2013</a:t>
+              <a:t>29/09/2013</a:t>
             </a:fld>
             <a:endParaRPr lang="en-US"/>
           </a:p>
@@ -1860,7 +1861,7 @@
             <a:fld id="{01A60C08-4C1E-4A5E-8023-A5E0FC3C95BF}" type="datetime1">
               <a:rPr lang="en-US" smtClean="0"/>
               <a:pPr/>
-              <a:t>28/09/2013</a:t>
+              <a:t>29/09/2013</a:t>
             </a:fld>
             <a:endParaRPr lang="en-US"/>
           </a:p>
@@ -2279,7 +2280,7 @@
             <a:fld id="{09D47052-F110-4E3C-AECC-18C80C202A55}" type="datetime1">
               <a:rPr lang="en-US" smtClean="0"/>
               <a:pPr/>
-              <a:t>28/09/2013</a:t>
+              <a:t>29/09/2013</a:t>
             </a:fld>
             <a:endParaRPr lang="en-US"/>
           </a:p>
@@ -2394,7 +2395,7 @@
             <a:fld id="{99128FCB-849C-48BB-9937-B98B744F5566}" type="datetime1">
               <a:rPr lang="en-US" smtClean="0"/>
               <a:pPr/>
-              <a:t>28/09/2013</a:t>
+              <a:t>29/09/2013</a:t>
             </a:fld>
             <a:endParaRPr lang="en-US"/>
           </a:p>
@@ -2486,7 +2487,7 @@
             <a:fld id="{6F9C919F-19E4-4AE1-9EDB-563194514575}" type="datetime1">
               <a:rPr lang="en-US" smtClean="0"/>
               <a:pPr/>
-              <a:t>28/09/2013</a:t>
+              <a:t>29/09/2013</a:t>
             </a:fld>
             <a:endParaRPr lang="en-US"/>
           </a:p>
@@ -2760,7 +2761,7 @@
             <a:fld id="{2785452C-574A-463A-8C57-608FFEEC5D39}" type="datetime1">
               <a:rPr lang="en-US" smtClean="0"/>
               <a:pPr/>
-              <a:t>28/09/2013</a:t>
+              <a:t>29/09/2013</a:t>
             </a:fld>
             <a:endParaRPr lang="en-US"/>
           </a:p>
@@ -3010,7 +3011,7 @@
             <a:fld id="{52B408A9-E92F-41C6-B584-B3E4F022331D}" type="datetime1">
               <a:rPr lang="en-US" smtClean="0"/>
               <a:pPr/>
-              <a:t>28/09/2013</a:t>
+              <a:t>29/09/2013</a:t>
             </a:fld>
             <a:endParaRPr lang="en-US"/>
           </a:p>
@@ -3220,7 +3221,7 @@
             <a:fld id="{2E53E5DE-F854-4244-8E83-4E7481A6E9A6}" type="datetime1">
               <a:rPr lang="en-US" smtClean="0"/>
               <a:pPr/>
-              <a:t>28/09/2013</a:t>
+              <a:t>29/09/2013</a:t>
             </a:fld>
             <a:endParaRPr lang="en-US"/>
           </a:p>
@@ -4380,6 +4381,108 @@
           <a:p>
             <a:r>
               <a:rPr lang="en-US" dirty="0" smtClean="0"/>
+              <a:t>Tasks of Mobile Cleaning Robot:</a:t>
+            </a:r>
+            <a:endParaRPr lang="en-US" dirty="0"/>
+          </a:p>
+        </p:txBody>
+      </p:sp>
+      <p:sp>
+        <p:nvSpPr>
+          <p:cNvPr id="4" name="Slide Number Placeholder 3"/>
+          <p:cNvSpPr>
+            <a:spLocks noGrp="1"/>
+          </p:cNvSpPr>
+          <p:nvPr>
+            <p:ph type="sldNum" sz="quarter" idx="12"/>
+          </p:nvPr>
+        </p:nvSpPr>
+        <p:spPr/>
+        <p:txBody>
+          <a:bodyPr/>
+          <a:lstStyle/>
+          <a:p>
+            <a:fld id="{41F30F6B-FB39-4EE3-BB70-00F6893EC94F}" type="slidenum">
+              <a:rPr lang="en-US" smtClean="0"/>
+              <a:pPr/>
+              <a:t>15</a:t>
+            </a:fld>
+            <a:endParaRPr lang="en-US"/>
+          </a:p>
+        </p:txBody>
+      </p:sp>
+      <p:pic>
+        <p:nvPicPr>
+          <p:cNvPr id="7" name="Content Placeholder 6" descr="Autopnp.png"/>
+          <p:cNvPicPr>
+            <a:picLocks noGrp="1" noChangeAspect="1"/>
+          </p:cNvPicPr>
+          <p:nvPr>
+            <p:ph idx="1"/>
+          </p:nvPr>
+        </p:nvPicPr>
+        <p:blipFill>
+          <a:blip r:embed="rId2"/>
+          <a:stretch>
+            <a:fillRect/>
+          </a:stretch>
+        </p:blipFill>
+        <p:spPr>
+          <a:xfrm>
+            <a:off x="0" y="1295400"/>
+            <a:ext cx="9143999" cy="5334000"/>
+          </a:xfrm>
+        </p:spPr>
+      </p:pic>
+    </p:spTree>
+  </p:cSld>
+  <p:clrMapOvr>
+    <a:masterClrMapping/>
+  </p:clrMapOvr>
+  <p:timing>
+    <p:tnLst>
+      <p:par>
+        <p:cTn id="1" dur="indefinite" restart="never" nodeType="tmRoot"/>
+      </p:par>
+    </p:tnLst>
+  </p:timing>
+</p:sld>
+</file>
+
+<file path=ppt/slides/slide16.xml><?xml version="1.0" encoding="utf-8"?>
+<p:sld xmlns:a="http://schemas.openxmlformats.org/drawingml/2006/main" xmlns:r="http://schemas.openxmlformats.org/officeDocument/2006/relationships" xmlns:p="http://schemas.openxmlformats.org/presentationml/2006/main">
+  <p:cSld>
+    <p:spTree>
+      <p:nvGrpSpPr>
+        <p:cNvPr id="1" name=""/>
+        <p:cNvGrpSpPr/>
+        <p:nvPr/>
+      </p:nvGrpSpPr>
+      <p:grpSpPr>
+        <a:xfrm>
+          <a:off x="0" y="0"/>
+          <a:ext cx="0" cy="0"/>
+          <a:chOff x="0" y="0"/>
+          <a:chExt cx="0" cy="0"/>
+        </a:xfrm>
+      </p:grpSpPr>
+      <p:sp>
+        <p:nvSpPr>
+          <p:cNvPr id="2" name="Title 1"/>
+          <p:cNvSpPr>
+            <a:spLocks noGrp="1"/>
+          </p:cNvSpPr>
+          <p:nvPr>
+            <p:ph type="title"/>
+          </p:nvPr>
+        </p:nvSpPr>
+        <p:spPr/>
+        <p:txBody>
+          <a:bodyPr/>
+          <a:lstStyle/>
+          <a:p>
+            <a:r>
+              <a:rPr lang="en-US" dirty="0" smtClean="0"/>
               <a:t>Video of Exploration Algorithm</a:t>
             </a:r>
             <a:endParaRPr lang="en-US" dirty="0"/>
@@ -4428,7 +4531,7 @@
             <a:fld id="{41F30F6B-FB39-4EE3-BB70-00F6893EC94F}" type="slidenum">
               <a:rPr lang="en-US" smtClean="0"/>
               <a:pPr/>
-              <a:t>15</a:t>
+              <a:t>16</a:t>
             </a:fld>
             <a:endParaRPr lang="en-US"/>
           </a:p>
@@ -4563,7 +4666,7 @@
 </p:sld>
 </file>
 
-<file path=ppt/slides/slide16.xml><?xml version="1.0" encoding="utf-8"?>
+<file path=ppt/slides/slide17.xml><?xml version="1.0" encoding="utf-8"?>
 <p:sld xmlns:a="http://schemas.openxmlformats.org/drawingml/2006/main" xmlns:r="http://schemas.openxmlformats.org/officeDocument/2006/relationships" xmlns:p="http://schemas.openxmlformats.org/presentationml/2006/main">
   <p:cSld>
     <p:spTree>
@@ -4679,28 +4782,16 @@
             </a:pPr>
             <a:r>
               <a:rPr lang="en-US" dirty="0" smtClean="0"/>
-              <a:t>o</a:t>
-            </a:r>
+              <a:t>or during the weekend. We can also use this</a:t>
+            </a:r>
+          </a:p>
+          <a:p>
+            <a:pPr algn="just">
+              <a:buNone/>
+            </a:pPr>
             <a:r>
               <a:rPr lang="en-US" dirty="0" smtClean="0"/>
-              <a:t>r during the weekend. We can also use this</a:t>
-            </a:r>
-          </a:p>
-          <a:p>
-            <a:pPr algn="just">
-              <a:buNone/>
-            </a:pPr>
-            <a:r>
-              <a:rPr lang="en-US" dirty="0" smtClean="0"/>
-              <a:t>algorithm </a:t>
-            </a:r>
-            <a:r>
-              <a:rPr lang="en-US" dirty="0" smtClean="0"/>
-              <a:t>in </a:t>
-            </a:r>
-            <a:r>
-              <a:rPr lang="en-US" dirty="0" smtClean="0"/>
-              <a:t>surveillance task and so on.</a:t>
+              <a:t>algorithm in surveillance task and so on.</a:t>
             </a:r>
             <a:endParaRPr lang="en-US" dirty="0"/>
           </a:p>
@@ -4748,7 +4839,7 @@
             <a:fld id="{41F30F6B-FB39-4EE3-BB70-00F6893EC94F}" type="slidenum">
               <a:rPr lang="en-US" smtClean="0"/>
               <a:pPr/>
-              <a:t>16</a:t>
+              <a:t>17</a:t>
             </a:fld>
             <a:endParaRPr lang="en-US"/>
           </a:p>
@@ -4769,7 +4860,7 @@
 </p:sld>
 </file>
 
-<file path=ppt/slides/slide17.xml><?xml version="1.0" encoding="utf-8"?>
+<file path=ppt/slides/slide18.xml><?xml version="1.0" encoding="utf-8"?>
 <p:sld xmlns:a="http://schemas.openxmlformats.org/drawingml/2006/main" xmlns:r="http://schemas.openxmlformats.org/officeDocument/2006/relationships" xmlns:p="http://schemas.openxmlformats.org/presentationml/2006/main">
   <p:cSld>
     <p:spTree>
@@ -4861,7 +4952,7 @@
             <a:fld id="{41F30F6B-FB39-4EE3-BB70-00F6893EC94F}" type="slidenum">
               <a:rPr lang="en-US" smtClean="0"/>
               <a:pPr/>
-              <a:t>17</a:t>
+              <a:t>18</a:t>
             </a:fld>
             <a:endParaRPr lang="en-US"/>
           </a:p>
@@ -5403,15 +5494,7 @@
           <a:p>
             <a:r>
               <a:rPr lang="en-US" dirty="0" smtClean="0"/>
-              <a:t>It helps the dirt detection algorithm to create a dirt map which </a:t>
-            </a:r>
-            <a:r>
-              <a:rPr lang="en-US" dirty="0" smtClean="0"/>
-              <a:t>is used later </a:t>
-            </a:r>
-            <a:r>
-              <a:rPr lang="en-US" dirty="0" smtClean="0"/>
-              <a:t>to detect dirt during cleaning.</a:t>
+              <a:t>It helps the dirt detection algorithm to create a dirt map which is used later to detect dirt during cleaning.</a:t>
             </a:r>
           </a:p>
           <a:p>

</xml_diff>